<commit_message>
fix: enforce strict Qdrant semantic vector search and restrict PostgreSQL usage to metadata & blob path retrieval
</commit_message>
<xml_diff>
--- a/TanishkaGupta Intern PPT.pptx
+++ b/TanishkaGupta Intern PPT.pptx
@@ -5,7 +5,7 @@
     <p:sldMasterId id="2147483648" r:id="rId1"/>
   </p:sldMasterIdLst>
   <p:notesMasterIdLst>
-    <p:notesMasterId r:id="rId14"/>
+    <p:notesMasterId r:id="rId13"/>
   </p:notesMasterIdLst>
   <p:sldIdLst>
     <p:sldId id="256" r:id="rId2"/>
@@ -15,11 +15,10 @@
     <p:sldId id="260" r:id="rId6"/>
     <p:sldId id="261" r:id="rId7"/>
     <p:sldId id="262" r:id="rId8"/>
-    <p:sldId id="263" r:id="rId9"/>
-    <p:sldId id="264" r:id="rId10"/>
-    <p:sldId id="265" r:id="rId11"/>
-    <p:sldId id="266" r:id="rId12"/>
-    <p:sldId id="267" r:id="rId13"/>
+    <p:sldId id="264" r:id="rId9"/>
+    <p:sldId id="265" r:id="rId10"/>
+    <p:sldId id="266" r:id="rId11"/>
+    <p:sldId id="267" r:id="rId12"/>
   </p:sldIdLst>
   <p:sldSz cx="12192000" cy="6858000"/>
   <p:notesSz cx="6858000" cy="12192000"/>
@@ -482,90 +481,6 @@
             <a:fld id="{F7021451-1387-4CA6-816F-3879F97B5CBC}" type="slidenum">
               <a:rPr lang="en-US"/>
               <a:t>11</a:t>
-            </a:fld>
-            <a:endParaRPr lang="en-US"/>
-          </a:p>
-        </p:txBody>
-      </p:sp>
-    </p:spTree>
-    <p:extLst>
-      <p:ext uri="{BB962C8B-B14F-4D97-AF65-F5344CB8AC3E}">
-        <p14:creationId xmlns:p14="http://schemas.microsoft.com/office/powerpoint/2010/main" val="1024086991"/>
-      </p:ext>
-    </p:extLst>
-  </p:cSld>
-  <p:clrMapOvr>
-    <a:masterClrMapping/>
-  </p:clrMapOvr>
-</p:notes>
-</file>
-
-<file path=ppt/notesSlides/notesSlide12.xml><?xml version="1.0" encoding="utf-8"?>
-<p:notes xmlns:a="http://schemas.openxmlformats.org/drawingml/2006/main" xmlns:r="http://schemas.openxmlformats.org/officeDocument/2006/relationships" xmlns:p="http://schemas.openxmlformats.org/presentationml/2006/main">
-  <p:cSld>
-    <p:spTree>
-      <p:nvGrpSpPr>
-        <p:cNvPr id="1" name=""/>
-        <p:cNvGrpSpPr/>
-        <p:nvPr/>
-      </p:nvGrpSpPr>
-      <p:grpSpPr>
-        <a:xfrm>
-          <a:off x="0" y="0"/>
-          <a:ext cx="0" cy="0"/>
-          <a:chOff x="0" y="0"/>
-          <a:chExt cx="0" cy="0"/>
-        </a:xfrm>
-      </p:grpSpPr>
-      <p:sp>
-        <p:nvSpPr>
-          <p:cNvPr id="2" name="Slide Image Placeholder 1"/>
-          <p:cNvSpPr>
-            <a:spLocks noGrp="1" noRot="1" noChangeAspect="1"/>
-          </p:cNvSpPr>
-          <p:nvPr>
-            <p:ph type="sldImg"/>
-          </p:nvPr>
-        </p:nvSpPr>
-        <p:spPr/>
-      </p:sp>
-      <p:sp>
-        <p:nvSpPr>
-          <p:cNvPr id="3" name="Notes Placeholder 2"/>
-          <p:cNvSpPr>
-            <a:spLocks noGrp="1"/>
-          </p:cNvSpPr>
-          <p:nvPr>
-            <p:ph type="body" idx="1"/>
-          </p:nvPr>
-        </p:nvSpPr>
-        <p:spPr/>
-        <p:txBody>
-          <a:bodyPr/>
-          <a:lstStyle/>
-          <a:p>
-            <a:endParaRPr lang="en-US" dirty="0"/>
-          </a:p>
-        </p:txBody>
-      </p:sp>
-      <p:sp>
-        <p:nvSpPr>
-          <p:cNvPr id="4" name="Slide Number Placeholder 3"/>
-          <p:cNvSpPr>
-            <a:spLocks noGrp="1"/>
-          </p:cNvSpPr>
-          <p:nvPr>
-            <p:ph type="sldNum" sz="quarter" idx="10"/>
-          </p:nvPr>
-        </p:nvSpPr>
-        <p:spPr/>
-        <p:txBody>
-          <a:bodyPr/>
-          <a:lstStyle/>
-          <a:p>
-            <a:fld id="{F7021451-1387-4CA6-816F-3879F97B5CBC}" type="slidenum">
-              <a:rPr lang="en-US"/>
-              <a:t>12</a:t>
             </a:fld>
             <a:endParaRPr lang="en-US"/>
           </a:p>
@@ -1739,7 +1654,7 @@
                 <a:ea typeface="Calibri" pitchFamily="34" charset="-122"/>
                 <a:cs typeface="Calibri" pitchFamily="34" charset="-120"/>
               </a:rPr>
-              <a:t>GenAI-Powered Multimodal OCR, Vector Search &amp; Cloud-Native Architecture</a:t>
+              <a:t>GenAI-Powered OCR, Vector Search &amp; Cloud-Native Architecture</a:t>
             </a:r>
             <a:endParaRPr lang="en-US" sz="1600" dirty="0"/>
           </a:p>
@@ -2025,8 +1940,8 @@
         </p:nvSpPr>
         <p:spPr>
           <a:xfrm>
-            <a:off x="1152731" y="4733980"/>
-            <a:ext cx="9601200" cy="914400"/>
+            <a:off x="1152731" y="4635505"/>
+            <a:ext cx="9601200" cy="1285142"/>
           </a:xfrm>
           <a:prstGeom prst="rect">
             <a:avLst/>
@@ -2119,6 +2034,36 @@
                 <a:cs typeface="Calibri" pitchFamily="34" charset="-120"/>
               </a:rPr>
               <a:t>Industry Mentor: Mr. Kailash Gupta – Senior Manager, Accounts</a:t>
+            </a:r>
+          </a:p>
+          <a:p>
+            <a:pPr marL="0" indent="0">
+              <a:lnSpc>
+                <a:spcPct val="130000"/>
+              </a:lnSpc>
+              <a:buNone/>
+            </a:pPr>
+            <a:r>
+              <a:rPr lang="en-US" sz="1400" dirty="0" err="1">
+                <a:solidFill>
+                  <a:schemeClr val="bg1"/>
+                </a:solidFill>
+                <a:latin typeface="Calibri" pitchFamily="34" charset="0"/>
+                <a:ea typeface="Calibri" pitchFamily="34" charset="-122"/>
+                <a:cs typeface="Calibri" pitchFamily="34" charset="-120"/>
+              </a:rPr>
+              <a:t>Organisation</a:t>
+            </a:r>
+            <a:r>
+              <a:rPr lang="en-US" sz="1400" dirty="0">
+                <a:solidFill>
+                  <a:schemeClr val="bg1"/>
+                </a:solidFill>
+                <a:latin typeface="Calibri" pitchFamily="34" charset="0"/>
+                <a:ea typeface="Calibri" pitchFamily="34" charset="-122"/>
+                <a:cs typeface="Calibri" pitchFamily="34" charset="-120"/>
+              </a:rPr>
+              <a:t> Name: DCM Shriram Ltd.</a:t>
             </a:r>
             <a:endParaRPr lang="en-US" sz="1400" dirty="0">
               <a:solidFill>
@@ -2137,502 +2082,6 @@
 </file>
 
 <file path=ppt/slides/slide10.xml><?xml version="1.0" encoding="utf-8"?>
-<p:sld xmlns:a="http://schemas.openxmlformats.org/drawingml/2006/main" xmlns:r="http://schemas.openxmlformats.org/officeDocument/2006/relationships" xmlns:p="http://schemas.openxmlformats.org/presentationml/2006/main">
-  <p:cSld name="Slide 10">
-    <p:bg>
-      <p:bgPr>
-        <a:solidFill>
-          <a:srgbClr val="FFFFFF"/>
-        </a:solidFill>
-        <a:effectLst/>
-      </p:bgPr>
-    </p:bg>
-    <p:spTree>
-      <p:nvGrpSpPr>
-        <p:cNvPr id="1" name=""/>
-        <p:cNvGrpSpPr/>
-        <p:nvPr/>
-      </p:nvGrpSpPr>
-      <p:grpSpPr>
-        <a:xfrm>
-          <a:off x="0" y="0"/>
-          <a:ext cx="0" cy="0"/>
-          <a:chOff x="0" y="0"/>
-          <a:chExt cx="0" cy="0"/>
-        </a:xfrm>
-      </p:grpSpPr>
-      <p:sp>
-        <p:nvSpPr>
-          <p:cNvPr id="2" name="Text 0"/>
-          <p:cNvSpPr/>
-          <p:nvPr/>
-        </p:nvSpPr>
-        <p:spPr>
-          <a:xfrm>
-            <a:off x="548640" y="384048"/>
-            <a:ext cx="11064240" cy="640080"/>
-          </a:xfrm>
-          <a:prstGeom prst="rect">
-            <a:avLst/>
-          </a:prstGeom>
-          <a:noFill/>
-          <a:ln/>
-        </p:spPr>
-        <p:txBody>
-          <a:bodyPr wrap="square" rtlCol="0" anchor="ctr"/>
-          <a:lstStyle/>
-          <a:p>
-            <a:pPr marL="0" indent="0" algn="l">
-              <a:buNone/>
-            </a:pPr>
-            <a:r>
-              <a:rPr lang="en-US" sz="3000" b="1" dirty="0">
-                <a:solidFill>
-                  <a:srgbClr val="1E2761"/>
-                </a:solidFill>
-                <a:latin typeface="Cambria" pitchFamily="34" charset="0"/>
-                <a:ea typeface="Cambria" pitchFamily="34" charset="-122"/>
-                <a:cs typeface="Cambria" pitchFamily="34" charset="-120"/>
-              </a:rPr>
-              <a:t>Development Methodology &amp; Verification</a:t>
-            </a:r>
-            <a:endParaRPr lang="en-US" sz="3000" dirty="0"/>
-          </a:p>
-        </p:txBody>
-      </p:sp>
-      <p:sp>
-        <p:nvSpPr>
-          <p:cNvPr id="3" name="Shape 1"/>
-          <p:cNvSpPr/>
-          <p:nvPr/>
-        </p:nvSpPr>
-        <p:spPr>
-          <a:xfrm>
-            <a:off x="644810" y="1122663"/>
-            <a:ext cx="2829910" cy="1163337"/>
-          </a:xfrm>
-          <a:prstGeom prst="roundRect">
-            <a:avLst>
-              <a:gd name="adj" fmla="val 2778"/>
-            </a:avLst>
-          </a:prstGeom>
-          <a:solidFill>
-            <a:srgbClr val="F7F8FC"/>
-          </a:solidFill>
-          <a:ln/>
-        </p:spPr>
-      </p:sp>
-      <p:sp>
-        <p:nvSpPr>
-          <p:cNvPr id="6" name="Text 3"/>
-          <p:cNvSpPr/>
-          <p:nvPr/>
-        </p:nvSpPr>
-        <p:spPr>
-          <a:xfrm>
-            <a:off x="613910" y="1122664"/>
-            <a:ext cx="3017520" cy="594360"/>
-          </a:xfrm>
-          <a:prstGeom prst="rect">
-            <a:avLst/>
-          </a:prstGeom>
-          <a:noFill/>
-          <a:ln/>
-        </p:spPr>
-        <p:txBody>
-          <a:bodyPr wrap="square" rtlCol="0" anchor="ctr"/>
-          <a:lstStyle/>
-          <a:p>
-            <a:pPr marL="0" indent="0" algn="ctr">
-              <a:buNone/>
-            </a:pPr>
-            <a:r>
-              <a:rPr lang="en-US" b="1" dirty="0">
-                <a:solidFill>
-                  <a:srgbClr val="1E2761"/>
-                </a:solidFill>
-                <a:latin typeface="Cambria" pitchFamily="34" charset="0"/>
-                <a:ea typeface="Cambria" pitchFamily="34" charset="-122"/>
-                <a:cs typeface="Cambria" pitchFamily="34" charset="-120"/>
-              </a:rPr>
-              <a:t>Agile Architecture</a:t>
-            </a:r>
-            <a:endParaRPr lang="en-US" dirty="0"/>
-          </a:p>
-        </p:txBody>
-      </p:sp>
-      <p:sp>
-        <p:nvSpPr>
-          <p:cNvPr id="7" name="Text 4"/>
-          <p:cNvSpPr/>
-          <p:nvPr/>
-        </p:nvSpPr>
-        <p:spPr>
-          <a:xfrm>
-            <a:off x="613910" y="1298450"/>
-            <a:ext cx="2926080" cy="1097280"/>
-          </a:xfrm>
-          <a:prstGeom prst="rect">
-            <a:avLst/>
-          </a:prstGeom>
-          <a:noFill/>
-          <a:ln/>
-        </p:spPr>
-        <p:txBody>
-          <a:bodyPr wrap="square" rtlCol="0" anchor="ctr"/>
-          <a:lstStyle/>
-          <a:p>
-            <a:pPr marL="0" indent="0" algn="ctr">
-              <a:lnSpc>
-                <a:spcPct val="125000"/>
-              </a:lnSpc>
-              <a:buNone/>
-            </a:pPr>
-            <a:r>
-              <a:rPr lang="en-US" sz="1600" dirty="0">
-                <a:solidFill>
-                  <a:srgbClr val="5A6072"/>
-                </a:solidFill>
-                <a:latin typeface="Calibri" pitchFamily="34" charset="0"/>
-                <a:ea typeface="Calibri" pitchFamily="34" charset="-122"/>
-                <a:cs typeface="Calibri" pitchFamily="34" charset="-120"/>
-              </a:rPr>
-              <a:t>Component-driven development with decoupled microservices.</a:t>
-            </a:r>
-            <a:endParaRPr lang="en-US" sz="1600" dirty="0"/>
-          </a:p>
-        </p:txBody>
-      </p:sp>
-      <p:sp>
-        <p:nvSpPr>
-          <p:cNvPr id="8" name="Shape 5"/>
-          <p:cNvSpPr/>
-          <p:nvPr/>
-        </p:nvSpPr>
-        <p:spPr>
-          <a:xfrm>
-            <a:off x="643233" y="2628900"/>
-            <a:ext cx="2831487" cy="1440180"/>
-          </a:xfrm>
-          <a:prstGeom prst="roundRect">
-            <a:avLst>
-              <a:gd name="adj" fmla="val 2778"/>
-            </a:avLst>
-          </a:prstGeom>
-          <a:solidFill>
-            <a:srgbClr val="F7F8FC"/>
-          </a:solidFill>
-          <a:ln/>
-        </p:spPr>
-      </p:sp>
-      <p:sp>
-        <p:nvSpPr>
-          <p:cNvPr id="11" name="Text 7"/>
-          <p:cNvSpPr/>
-          <p:nvPr/>
-        </p:nvSpPr>
-        <p:spPr>
-          <a:xfrm>
-            <a:off x="548640" y="2583180"/>
-            <a:ext cx="3017520" cy="594360"/>
-          </a:xfrm>
-          <a:prstGeom prst="rect">
-            <a:avLst/>
-          </a:prstGeom>
-          <a:noFill/>
-          <a:ln/>
-        </p:spPr>
-        <p:txBody>
-          <a:bodyPr wrap="square" rtlCol="0" anchor="ctr"/>
-          <a:lstStyle/>
-          <a:p>
-            <a:pPr marL="0" indent="0" algn="ctr">
-              <a:buNone/>
-            </a:pPr>
-            <a:r>
-              <a:rPr lang="en-US" b="1" dirty="0">
-                <a:solidFill>
-                  <a:srgbClr val="1E2761"/>
-                </a:solidFill>
-                <a:latin typeface="Cambria" pitchFamily="34" charset="0"/>
-                <a:ea typeface="Cambria" pitchFamily="34" charset="-122"/>
-                <a:cs typeface="Cambria" pitchFamily="34" charset="-120"/>
-              </a:rPr>
-              <a:t>AI-Assisted Prototyping</a:t>
-            </a:r>
-            <a:endParaRPr lang="en-US" dirty="0"/>
-          </a:p>
-        </p:txBody>
-      </p:sp>
-      <p:sp>
-        <p:nvSpPr>
-          <p:cNvPr id="12" name="Text 8"/>
-          <p:cNvSpPr/>
-          <p:nvPr/>
-        </p:nvSpPr>
-        <p:spPr>
-          <a:xfrm>
-            <a:off x="548640" y="2971800"/>
-            <a:ext cx="2926080" cy="1097280"/>
-          </a:xfrm>
-          <a:prstGeom prst="rect">
-            <a:avLst/>
-          </a:prstGeom>
-          <a:noFill/>
-          <a:ln/>
-        </p:spPr>
-        <p:txBody>
-          <a:bodyPr wrap="square" rtlCol="0" anchor="ctr"/>
-          <a:lstStyle/>
-          <a:p>
-            <a:pPr marL="0" indent="0" algn="ctr">
-              <a:lnSpc>
-                <a:spcPct val="125000"/>
-              </a:lnSpc>
-              <a:buNone/>
-            </a:pPr>
-            <a:r>
-              <a:rPr lang="en-US" sz="1600" dirty="0">
-                <a:solidFill>
-                  <a:srgbClr val="5A6072"/>
-                </a:solidFill>
-                <a:latin typeface="Calibri" pitchFamily="34" charset="0"/>
-                <a:ea typeface="Calibri" pitchFamily="34" charset="-122"/>
-                <a:cs typeface="Calibri" pitchFamily="34" charset="-120"/>
-              </a:rPr>
-              <a:t>Accelerated schema design, FastAPI route setup, and container orchestration.</a:t>
-            </a:r>
-            <a:endParaRPr lang="en-US" sz="1600" dirty="0"/>
-          </a:p>
-        </p:txBody>
-      </p:sp>
-      <p:sp>
-        <p:nvSpPr>
-          <p:cNvPr id="13" name="Shape 9"/>
-          <p:cNvSpPr/>
-          <p:nvPr/>
-        </p:nvSpPr>
-        <p:spPr>
-          <a:xfrm>
-            <a:off x="643232" y="4274820"/>
-            <a:ext cx="2831488" cy="1783080"/>
-          </a:xfrm>
-          <a:prstGeom prst="roundRect">
-            <a:avLst>
-              <a:gd name="adj" fmla="val 2778"/>
-            </a:avLst>
-          </a:prstGeom>
-          <a:solidFill>
-            <a:srgbClr val="F7F8FC"/>
-          </a:solidFill>
-          <a:ln/>
-        </p:spPr>
-        <p:txBody>
-          <a:bodyPr/>
-          <a:lstStyle/>
-          <a:p>
-            <a:endParaRPr lang="en-IN" dirty="0"/>
-          </a:p>
-        </p:txBody>
-      </p:sp>
-      <p:sp>
-        <p:nvSpPr>
-          <p:cNvPr id="16" name="Text 11"/>
-          <p:cNvSpPr/>
-          <p:nvPr/>
-        </p:nvSpPr>
-        <p:spPr>
-          <a:xfrm>
-            <a:off x="435127" y="4229100"/>
-            <a:ext cx="3139295" cy="594360"/>
-          </a:xfrm>
-          <a:prstGeom prst="rect">
-            <a:avLst/>
-          </a:prstGeom>
-          <a:noFill/>
-          <a:ln/>
-        </p:spPr>
-        <p:txBody>
-          <a:bodyPr wrap="square" rtlCol="0" anchor="ctr"/>
-          <a:lstStyle/>
-          <a:p>
-            <a:pPr marL="0" indent="0" algn="ctr">
-              <a:buNone/>
-            </a:pPr>
-            <a:r>
-              <a:rPr lang="en-US" b="1" dirty="0">
-                <a:solidFill>
-                  <a:srgbClr val="1E2761"/>
-                </a:solidFill>
-                <a:latin typeface="Cambria" pitchFamily="34" charset="0"/>
-                <a:ea typeface="Cambria" pitchFamily="34" charset="-122"/>
-                <a:cs typeface="Cambria" pitchFamily="34" charset="-120"/>
-              </a:rPr>
-              <a:t>  Verification &amp; Testing</a:t>
-            </a:r>
-            <a:endParaRPr lang="en-US" dirty="0"/>
-          </a:p>
-        </p:txBody>
-      </p:sp>
-      <p:sp>
-        <p:nvSpPr>
-          <p:cNvPr id="17" name="Text 12"/>
-          <p:cNvSpPr/>
-          <p:nvPr/>
-        </p:nvSpPr>
-        <p:spPr>
-          <a:xfrm>
-            <a:off x="480847" y="4823460"/>
-            <a:ext cx="3044165" cy="1097280"/>
-          </a:xfrm>
-          <a:prstGeom prst="rect">
-            <a:avLst/>
-          </a:prstGeom>
-          <a:noFill/>
-          <a:ln/>
-        </p:spPr>
-        <p:txBody>
-          <a:bodyPr wrap="square" rtlCol="0" anchor="ctr"/>
-          <a:lstStyle/>
-          <a:p>
-            <a:pPr marL="0" indent="0" algn="ctr">
-              <a:lnSpc>
-                <a:spcPct val="125000"/>
-              </a:lnSpc>
-              <a:buNone/>
-            </a:pPr>
-            <a:r>
-              <a:rPr lang="en-US" sz="1600" dirty="0">
-                <a:solidFill>
-                  <a:srgbClr val="5A6072"/>
-                </a:solidFill>
-                <a:latin typeface="Calibri" pitchFamily="34" charset="0"/>
-                <a:ea typeface="Calibri" pitchFamily="34" charset="-122"/>
-                <a:cs typeface="Calibri" pitchFamily="34" charset="-120"/>
-              </a:rPr>
-              <a:t>End-to-end validation of PDF stream upload, vector scoring accuracy, and database transactions.</a:t>
-            </a:r>
-            <a:endParaRPr lang="en-US" sz="1600" dirty="0"/>
-          </a:p>
-        </p:txBody>
-      </p:sp>
-      <p:sp>
-        <p:nvSpPr>
-          <p:cNvPr id="18" name="Text 13"/>
-          <p:cNvSpPr/>
-          <p:nvPr/>
-        </p:nvSpPr>
-        <p:spPr>
-          <a:xfrm>
-            <a:off x="457200" y="6565392"/>
-            <a:ext cx="8229600" cy="274320"/>
-          </a:xfrm>
-          <a:prstGeom prst="rect">
-            <a:avLst/>
-          </a:prstGeom>
-          <a:noFill/>
-          <a:ln/>
-        </p:spPr>
-        <p:txBody>
-          <a:bodyPr wrap="square" rtlCol="0" anchor="ctr"/>
-          <a:lstStyle/>
-          <a:p>
-            <a:pPr marL="0" indent="0" algn="l">
-              <a:buNone/>
-            </a:pPr>
-            <a:r>
-              <a:rPr lang="en-US" sz="900" dirty="0">
-                <a:solidFill>
-                  <a:srgbClr val="8A90A6"/>
-                </a:solidFill>
-                <a:latin typeface="Calibri" pitchFamily="34" charset="0"/>
-                <a:ea typeface="Calibri" pitchFamily="34" charset="-122"/>
-                <a:cs typeface="Calibri" pitchFamily="34" charset="-120"/>
-              </a:rPr>
-              <a:t>Intelligent Invoice Processing &amp; Semantic Search Engine</a:t>
-            </a:r>
-            <a:endParaRPr lang="en-US" sz="900" dirty="0"/>
-          </a:p>
-        </p:txBody>
-      </p:sp>
-      <p:sp>
-        <p:nvSpPr>
-          <p:cNvPr id="19" name="Text 14"/>
-          <p:cNvSpPr/>
-          <p:nvPr/>
-        </p:nvSpPr>
-        <p:spPr>
-          <a:xfrm>
-            <a:off x="11521440" y="6565392"/>
-            <a:ext cx="457200" cy="274320"/>
-          </a:xfrm>
-          <a:prstGeom prst="rect">
-            <a:avLst/>
-          </a:prstGeom>
-          <a:noFill/>
-          <a:ln/>
-        </p:spPr>
-        <p:txBody>
-          <a:bodyPr wrap="square" rtlCol="0" anchor="ctr"/>
-          <a:lstStyle/>
-          <a:p>
-            <a:pPr marL="0" indent="0" algn="r">
-              <a:buNone/>
-            </a:pPr>
-            <a:r>
-              <a:rPr lang="en-US" sz="900" dirty="0">
-                <a:solidFill>
-                  <a:srgbClr val="8A90A6"/>
-                </a:solidFill>
-                <a:latin typeface="Calibri" pitchFamily="34" charset="0"/>
-                <a:ea typeface="Calibri" pitchFamily="34" charset="-122"/>
-                <a:cs typeface="Calibri" pitchFamily="34" charset="-120"/>
-              </a:rPr>
-              <a:t>10</a:t>
-            </a:r>
-            <a:endParaRPr lang="en-US" sz="900" dirty="0"/>
-          </a:p>
-        </p:txBody>
-      </p:sp>
-      <p:pic>
-        <p:nvPicPr>
-          <p:cNvPr id="27" name="Picture 26">
-            <a:extLst>
-              <a:ext uri="{FF2B5EF4-FFF2-40B4-BE49-F238E27FC236}">
-                <a16:creationId xmlns:a16="http://schemas.microsoft.com/office/drawing/2014/main" id="{6E9E7167-BC39-CD5D-D84A-6AB8AF28E16B}"/>
-              </a:ext>
-            </a:extLst>
-          </p:cNvPr>
-          <p:cNvPicPr>
-            <a:picLocks noChangeAspect="1"/>
-          </p:cNvPicPr>
-          <p:nvPr/>
-        </p:nvPicPr>
-        <p:blipFill>
-          <a:blip r:embed="rId3"/>
-          <a:stretch>
-            <a:fillRect/>
-          </a:stretch>
-        </p:blipFill>
-        <p:spPr>
-          <a:xfrm>
-            <a:off x="3748095" y="1298450"/>
-            <a:ext cx="8203082" cy="4547288"/>
-          </a:xfrm>
-          <a:prstGeom prst="rect">
-            <a:avLst/>
-          </a:prstGeom>
-        </p:spPr>
-      </p:pic>
-    </p:spTree>
-  </p:cSld>
-  <p:clrMapOvr>
-    <a:masterClrMapping/>
-  </p:clrMapOvr>
-</p:sld>
-</file>
-
-<file path=ppt/slides/slide11.xml><?xml version="1.0" encoding="utf-8"?>
 <p:sld xmlns:a="http://schemas.openxmlformats.org/drawingml/2006/main" xmlns:r="http://schemas.openxmlformats.org/officeDocument/2006/relationships" xmlns:p="http://schemas.openxmlformats.org/presentationml/2006/main">
   <p:cSld name="Slide 11">
     <p:bg>
@@ -3145,7 +2594,7 @@
         </p:nvSpPr>
         <p:spPr>
           <a:xfrm>
-            <a:off x="6309360" y="3227832"/>
+            <a:off x="6284169" y="3464475"/>
             <a:ext cx="384048" cy="384048"/>
           </a:xfrm>
           <a:prstGeom prst="ellipse">
@@ -3165,7 +2614,7 @@
         </p:nvSpPr>
         <p:spPr>
           <a:xfrm>
-            <a:off x="6309360" y="3227832"/>
+            <a:off x="6284169" y="3474169"/>
             <a:ext cx="384048" cy="384048"/>
           </a:xfrm>
           <a:prstGeom prst="rect">
@@ -3204,7 +2653,7 @@
         </p:nvSpPr>
         <p:spPr>
           <a:xfrm>
-            <a:off x="6812280" y="3172968"/>
+            <a:off x="6805041" y="3376737"/>
             <a:ext cx="4663440" cy="320040"/>
           </a:xfrm>
           <a:prstGeom prst="rect">
@@ -3243,7 +2692,7 @@
         </p:nvSpPr>
         <p:spPr>
           <a:xfrm>
-            <a:off x="6812280" y="3474720"/>
+            <a:off x="6805041" y="3675337"/>
             <a:ext cx="4663440" cy="502920"/>
           </a:xfrm>
           <a:prstGeom prst="rect">
@@ -3279,13 +2728,41 @@
       </p:sp>
       <p:sp>
         <p:nvSpPr>
-          <p:cNvPr id="21" name="Shape 17"/>
+          <p:cNvPr id="22" name="Text 18"/>
           <p:cNvSpPr/>
           <p:nvPr/>
         </p:nvSpPr>
         <p:spPr>
           <a:xfrm>
             <a:off x="6309360" y="4123944"/>
+            <a:ext cx="384048" cy="384048"/>
+          </a:xfrm>
+          <a:prstGeom prst="rect">
+            <a:avLst/>
+          </a:prstGeom>
+          <a:noFill/>
+          <a:ln/>
+        </p:spPr>
+        <p:txBody>
+          <a:bodyPr wrap="square" rtlCol="0" anchor="ctr"/>
+          <a:lstStyle/>
+          <a:p>
+            <a:pPr marL="0" indent="0" algn="ctr">
+              <a:buNone/>
+            </a:pPr>
+            <a:endParaRPr lang="en-US" sz="1400" dirty="0"/>
+          </a:p>
+        </p:txBody>
+      </p:sp>
+      <p:sp>
+        <p:nvSpPr>
+          <p:cNvPr id="25" name="Shape 21"/>
+          <p:cNvSpPr/>
+          <p:nvPr/>
+        </p:nvSpPr>
+        <p:spPr>
+          <a:xfrm>
+            <a:off x="6284169" y="4329526"/>
             <a:ext cx="384048" cy="384048"/>
           </a:xfrm>
           <a:prstGeom prst="ellipse">
@@ -3299,13 +2776,13 @@
       </p:sp>
       <p:sp>
         <p:nvSpPr>
-          <p:cNvPr id="22" name="Text 18"/>
-          <p:cNvSpPr/>
-          <p:nvPr/>
-        </p:nvSpPr>
-        <p:spPr>
-          <a:xfrm>
-            <a:off x="6309360" y="4123944"/>
+          <p:cNvPr id="26" name="Text 22"/>
+          <p:cNvSpPr/>
+          <p:nvPr/>
+        </p:nvSpPr>
+        <p:spPr>
+          <a:xfrm>
+            <a:off x="6276594" y="4326611"/>
             <a:ext cx="384048" cy="384048"/>
           </a:xfrm>
           <a:prstGeom prst="rect">
@@ -3319,6 +2796,44 @@
           <a:lstStyle/>
           <a:p>
             <a:pPr marL="0" indent="0" algn="ctr">
+              <a:buNone/>
+            </a:pPr>
+            <a:r>
+              <a:rPr lang="en-US" sz="1400" b="1" dirty="0">
+                <a:solidFill>
+                  <a:srgbClr val="FFFFFF"/>
+                </a:solidFill>
+                <a:latin typeface="Cambria" pitchFamily="34" charset="0"/>
+                <a:ea typeface="Cambria" pitchFamily="34" charset="-122"/>
+              </a:rPr>
+              <a:t>3</a:t>
+            </a:r>
+            <a:endParaRPr lang="en-US" sz="1400" dirty="0"/>
+          </a:p>
+        </p:txBody>
+      </p:sp>
+      <p:sp>
+        <p:nvSpPr>
+          <p:cNvPr id="27" name="Text 23"/>
+          <p:cNvSpPr/>
+          <p:nvPr/>
+        </p:nvSpPr>
+        <p:spPr>
+          <a:xfrm>
+            <a:off x="6821424" y="4279392"/>
+            <a:ext cx="4663440" cy="320040"/>
+          </a:xfrm>
+          <a:prstGeom prst="rect">
+            <a:avLst/>
+          </a:prstGeom>
+          <a:noFill/>
+          <a:ln/>
+        </p:spPr>
+        <p:txBody>
+          <a:bodyPr wrap="square" rtlCol="0" anchor="ctr"/>
+          <a:lstStyle/>
+          <a:p>
+            <a:pPr marL="0" indent="0">
               <a:buNone/>
             </a:pPr>
             <a:r>
@@ -3330,7 +2845,7 @@
                 <a:ea typeface="Cambria" pitchFamily="34" charset="-122"/>
                 <a:cs typeface="Cambria" pitchFamily="34" charset="-120"/>
               </a:rPr>
-              <a:t>3</a:t>
+              <a:t>Security &amp; RBAC</a:t>
             </a:r>
             <a:endParaRPr lang="en-US" sz="1400" dirty="0"/>
           </a:p>
@@ -3338,52 +2853,13 @@
       </p:sp>
       <p:sp>
         <p:nvSpPr>
-          <p:cNvPr id="23" name="Text 19"/>
-          <p:cNvSpPr/>
-          <p:nvPr/>
-        </p:nvSpPr>
-        <p:spPr>
-          <a:xfrm>
-            <a:off x="6812280" y="4069080"/>
-            <a:ext cx="4663440" cy="320040"/>
-          </a:xfrm>
-          <a:prstGeom prst="rect">
-            <a:avLst/>
-          </a:prstGeom>
-          <a:noFill/>
-          <a:ln/>
-        </p:spPr>
-        <p:txBody>
-          <a:bodyPr wrap="square" rtlCol="0" anchor="ctr"/>
-          <a:lstStyle/>
-          <a:p>
-            <a:pPr marL="0" indent="0">
-              <a:buNone/>
-            </a:pPr>
-            <a:r>
-              <a:rPr lang="en-US" sz="1400" b="1" dirty="0">
-                <a:solidFill>
-                  <a:srgbClr val="FFFFFF"/>
-                </a:solidFill>
-                <a:latin typeface="Cambria" pitchFamily="34" charset="0"/>
-                <a:ea typeface="Cambria" pitchFamily="34" charset="-122"/>
-                <a:cs typeface="Cambria" pitchFamily="34" charset="-120"/>
-              </a:rPr>
-              <a:t>Fine-Tuned LLM Embeddings</a:t>
-            </a:r>
-            <a:endParaRPr lang="en-US" sz="1400" dirty="0"/>
-          </a:p>
-        </p:txBody>
-      </p:sp>
-      <p:sp>
-        <p:nvSpPr>
-          <p:cNvPr id="24" name="Text 20"/>
-          <p:cNvSpPr/>
-          <p:nvPr/>
-        </p:nvSpPr>
-        <p:spPr>
-          <a:xfrm>
-            <a:off x="6812280" y="4370832"/>
+          <p:cNvPr id="28" name="Text 24"/>
+          <p:cNvSpPr/>
+          <p:nvPr/>
+        </p:nvSpPr>
+        <p:spPr>
+          <a:xfrm>
+            <a:off x="6805041" y="4521550"/>
             <a:ext cx="4663440" cy="502920"/>
           </a:xfrm>
           <a:prstGeom prst="rect">
@@ -3411,7 +2887,7 @@
                 <a:ea typeface="Calibri" pitchFamily="34" charset="-122"/>
                 <a:cs typeface="Calibri" pitchFamily="34" charset="-120"/>
               </a:rPr>
-              <a:t>Specialized domain transformers (e.g., FinBERT) for complex financial syntax.</a:t>
+              <a:t>JWT authentication and role-based multi-tenant isolation.</a:t>
             </a:r>
             <a:endParaRPr lang="en-US" sz="1400" dirty="0"/>
           </a:p>
@@ -3419,153 +2895,13 @@
       </p:sp>
       <p:sp>
         <p:nvSpPr>
-          <p:cNvPr id="25" name="Shape 21"/>
-          <p:cNvSpPr/>
-          <p:nvPr/>
-        </p:nvSpPr>
-        <p:spPr>
-          <a:xfrm>
-            <a:off x="6309360" y="5020056"/>
-            <a:ext cx="384048" cy="384048"/>
-          </a:xfrm>
-          <a:prstGeom prst="ellipse">
-            <a:avLst/>
-          </a:prstGeom>
-          <a:solidFill>
-            <a:srgbClr val="3D8BFF"/>
-          </a:solidFill>
-          <a:ln/>
-        </p:spPr>
-      </p:sp>
-      <p:sp>
-        <p:nvSpPr>
-          <p:cNvPr id="26" name="Text 22"/>
-          <p:cNvSpPr/>
-          <p:nvPr/>
-        </p:nvSpPr>
-        <p:spPr>
-          <a:xfrm>
-            <a:off x="6309360" y="5020056"/>
-            <a:ext cx="384048" cy="384048"/>
-          </a:xfrm>
-          <a:prstGeom prst="rect">
-            <a:avLst/>
-          </a:prstGeom>
-          <a:noFill/>
-          <a:ln/>
-        </p:spPr>
-        <p:txBody>
-          <a:bodyPr wrap="square" rtlCol="0" anchor="ctr"/>
-          <a:lstStyle/>
-          <a:p>
-            <a:pPr marL="0" indent="0" algn="ctr">
-              <a:buNone/>
-            </a:pPr>
-            <a:r>
-              <a:rPr lang="en-US" sz="1400" b="1" dirty="0">
-                <a:solidFill>
-                  <a:srgbClr val="FFFFFF"/>
-                </a:solidFill>
-                <a:latin typeface="Cambria" pitchFamily="34" charset="0"/>
-                <a:ea typeface="Cambria" pitchFamily="34" charset="-122"/>
-                <a:cs typeface="Cambria" pitchFamily="34" charset="-120"/>
-              </a:rPr>
-              <a:t>4</a:t>
-            </a:r>
-            <a:endParaRPr lang="en-US" sz="1400" dirty="0"/>
-          </a:p>
-        </p:txBody>
-      </p:sp>
-      <p:sp>
-        <p:nvSpPr>
-          <p:cNvPr id="27" name="Text 23"/>
-          <p:cNvSpPr/>
-          <p:nvPr/>
-        </p:nvSpPr>
-        <p:spPr>
-          <a:xfrm>
-            <a:off x="6812280" y="4965192"/>
-            <a:ext cx="4663440" cy="320040"/>
-          </a:xfrm>
-          <a:prstGeom prst="rect">
-            <a:avLst/>
-          </a:prstGeom>
-          <a:noFill/>
-          <a:ln/>
-        </p:spPr>
-        <p:txBody>
-          <a:bodyPr wrap="square" rtlCol="0" anchor="ctr"/>
-          <a:lstStyle/>
-          <a:p>
-            <a:pPr marL="0" indent="0">
-              <a:buNone/>
-            </a:pPr>
-            <a:r>
-              <a:rPr lang="en-US" sz="1400" b="1" dirty="0">
-                <a:solidFill>
-                  <a:srgbClr val="FFFFFF"/>
-                </a:solidFill>
-                <a:latin typeface="Cambria" pitchFamily="34" charset="0"/>
-                <a:ea typeface="Cambria" pitchFamily="34" charset="-122"/>
-                <a:cs typeface="Cambria" pitchFamily="34" charset="-120"/>
-              </a:rPr>
-              <a:t>Security &amp; RBAC</a:t>
-            </a:r>
-            <a:endParaRPr lang="en-US" sz="1400" dirty="0"/>
-          </a:p>
-        </p:txBody>
-      </p:sp>
-      <p:sp>
-        <p:nvSpPr>
-          <p:cNvPr id="28" name="Text 24"/>
-          <p:cNvSpPr/>
-          <p:nvPr/>
-        </p:nvSpPr>
-        <p:spPr>
-          <a:xfrm>
-            <a:off x="6812280" y="5175504"/>
-            <a:ext cx="4663440" cy="502920"/>
-          </a:xfrm>
-          <a:prstGeom prst="rect">
-            <a:avLst/>
-          </a:prstGeom>
-          <a:noFill/>
-          <a:ln/>
-        </p:spPr>
-        <p:txBody>
-          <a:bodyPr wrap="square" rtlCol="0" anchor="ctr"/>
-          <a:lstStyle/>
-          <a:p>
-            <a:pPr marL="0" indent="0">
-              <a:lnSpc>
-                <a:spcPct val="115000"/>
-              </a:lnSpc>
-              <a:buNone/>
-            </a:pPr>
-            <a:r>
-              <a:rPr lang="en-US" sz="1400" dirty="0">
-                <a:solidFill>
-                  <a:srgbClr val="C7CCEC"/>
-                </a:solidFill>
-                <a:latin typeface="Calibri" pitchFamily="34" charset="0"/>
-                <a:ea typeface="Calibri" pitchFamily="34" charset="-122"/>
-                <a:cs typeface="Calibri" pitchFamily="34" charset="-120"/>
-              </a:rPr>
-              <a:t>JWT authentication and role-based multi-tenant isolation.</a:t>
-            </a:r>
-            <a:endParaRPr lang="en-US" sz="1400" dirty="0"/>
-          </a:p>
-        </p:txBody>
-      </p:sp>
-      <p:sp>
-        <p:nvSpPr>
           <p:cNvPr id="29" name="Text 25"/>
           <p:cNvSpPr/>
           <p:nvPr/>
         </p:nvSpPr>
         <p:spPr>
           <a:xfrm>
-            <a:off x="457200" y="6565392"/>
+            <a:off x="465083" y="6565392"/>
             <a:ext cx="8229600" cy="274320"/>
           </a:xfrm>
           <a:prstGeom prst="rect">
@@ -3643,7 +2979,7 @@
 </p:sld>
 </file>
 
-<file path=ppt/slides/slide12.xml><?xml version="1.0" encoding="utf-8"?>
+<file path=ppt/slides/slide11.xml><?xml version="1.0" encoding="utf-8"?>
 <p:sld xmlns:a="http://schemas.openxmlformats.org/drawingml/2006/main" xmlns:r="http://schemas.openxmlformats.org/officeDocument/2006/relationships" xmlns:p="http://schemas.openxmlformats.org/presentationml/2006/main">
   <p:cSld name="Slide 12">
     <p:bg>
@@ -10078,1127 +9414,6 @@
 
 <file path=ppt/slides/slide8.xml><?xml version="1.0" encoding="utf-8"?>
 <p:sld xmlns:a="http://schemas.openxmlformats.org/drawingml/2006/main" xmlns:r="http://schemas.openxmlformats.org/officeDocument/2006/relationships" xmlns:p="http://schemas.openxmlformats.org/presentationml/2006/main">
-  <p:cSld name="Slide 8">
-    <p:bg>
-      <p:bgPr>
-        <a:solidFill>
-          <a:srgbClr val="F7F8FC"/>
-        </a:solidFill>
-        <a:effectLst/>
-      </p:bgPr>
-    </p:bg>
-    <p:spTree>
-      <p:nvGrpSpPr>
-        <p:cNvPr id="1" name=""/>
-        <p:cNvGrpSpPr/>
-        <p:nvPr/>
-      </p:nvGrpSpPr>
-      <p:grpSpPr>
-        <a:xfrm>
-          <a:off x="0" y="0"/>
-          <a:ext cx="0" cy="0"/>
-          <a:chOff x="0" y="0"/>
-          <a:chExt cx="0" cy="0"/>
-        </a:xfrm>
-      </p:grpSpPr>
-      <p:sp>
-        <p:nvSpPr>
-          <p:cNvPr id="2" name="Text 0"/>
-          <p:cNvSpPr/>
-          <p:nvPr/>
-        </p:nvSpPr>
-        <p:spPr>
-          <a:xfrm>
-            <a:off x="548640" y="384048"/>
-            <a:ext cx="11064240" cy="640080"/>
-          </a:xfrm>
-          <a:prstGeom prst="rect">
-            <a:avLst/>
-          </a:prstGeom>
-          <a:noFill/>
-          <a:ln/>
-        </p:spPr>
-        <p:txBody>
-          <a:bodyPr wrap="square" rtlCol="0" anchor="ctr"/>
-          <a:lstStyle/>
-          <a:p>
-            <a:pPr marL="0" indent="0" algn="l">
-              <a:buNone/>
-            </a:pPr>
-            <a:r>
-              <a:rPr lang="en-US" sz="3000" b="1" dirty="0">
-                <a:solidFill>
-                  <a:srgbClr val="1E2761"/>
-                </a:solidFill>
-                <a:latin typeface="Cambria" pitchFamily="34" charset="0"/>
-                <a:ea typeface="Cambria" pitchFamily="34" charset="-122"/>
-                <a:cs typeface="Cambria" pitchFamily="34" charset="-120"/>
-              </a:rPr>
-              <a:t>Document AI Extraction &amp; Semantic Search Workflow</a:t>
-            </a:r>
-            <a:endParaRPr lang="en-US" sz="3000" dirty="0"/>
-          </a:p>
-        </p:txBody>
-      </p:sp>
-      <p:sp>
-        <p:nvSpPr>
-          <p:cNvPr id="3" name="Shape 1"/>
-          <p:cNvSpPr/>
-          <p:nvPr/>
-        </p:nvSpPr>
-        <p:spPr>
-          <a:xfrm>
-            <a:off x="1577340" y="1783080"/>
-            <a:ext cx="640080" cy="640080"/>
-          </a:xfrm>
-          <a:prstGeom prst="ellipse">
-            <a:avLst/>
-          </a:prstGeom>
-          <a:solidFill>
-            <a:srgbClr val="1E2761"/>
-          </a:solidFill>
-          <a:ln w="38100">
-            <a:solidFill>
-              <a:srgbClr val="FFFFFF"/>
-            </a:solidFill>
-            <a:prstDash val="solid"/>
-          </a:ln>
-        </p:spPr>
-      </p:sp>
-      <p:sp>
-        <p:nvSpPr>
-          <p:cNvPr id="4" name="Text 2"/>
-          <p:cNvSpPr/>
-          <p:nvPr/>
-        </p:nvSpPr>
-        <p:spPr>
-          <a:xfrm>
-            <a:off x="1577340" y="1783080"/>
-            <a:ext cx="640080" cy="640080"/>
-          </a:xfrm>
-          <a:prstGeom prst="rect">
-            <a:avLst/>
-          </a:prstGeom>
-          <a:noFill/>
-          <a:ln/>
-        </p:spPr>
-        <p:txBody>
-          <a:bodyPr wrap="square" rtlCol="0" anchor="ctr"/>
-          <a:lstStyle/>
-          <a:p>
-            <a:pPr marL="0" indent="0" algn="ctr">
-              <a:buNone/>
-            </a:pPr>
-            <a:r>
-              <a:rPr lang="en-US" sz="1800" b="1" dirty="0">
-                <a:solidFill>
-                  <a:srgbClr val="FFFFFF"/>
-                </a:solidFill>
-                <a:latin typeface="Cambria" pitchFamily="34" charset="0"/>
-                <a:ea typeface="Cambria" pitchFamily="34" charset="-122"/>
-                <a:cs typeface="Cambria" pitchFamily="34" charset="-120"/>
-              </a:rPr>
-              <a:t>1</a:t>
-            </a:r>
-            <a:endParaRPr lang="en-US" sz="1800" dirty="0"/>
-          </a:p>
-        </p:txBody>
-      </p:sp>
-      <p:sp>
-        <p:nvSpPr>
-          <p:cNvPr id="5" name="Shape 3"/>
-          <p:cNvSpPr/>
-          <p:nvPr/>
-        </p:nvSpPr>
-        <p:spPr>
-          <a:xfrm>
-            <a:off x="685800" y="2560320"/>
-            <a:ext cx="2423160" cy="2834640"/>
-          </a:xfrm>
-          <a:prstGeom prst="roundRect">
-            <a:avLst>
-              <a:gd name="adj" fmla="val 3019"/>
-            </a:avLst>
-          </a:prstGeom>
-          <a:solidFill>
-            <a:srgbClr val="FFFFFF"/>
-          </a:solidFill>
-          <a:ln w="12700">
-            <a:solidFill>
-              <a:srgbClr val="DCE1F2"/>
-            </a:solidFill>
-            <a:prstDash val="solid"/>
-          </a:ln>
-          <a:effectLst>
-            <a:outerShdw blurRad="76200" dist="25400" dir="5400000" algn="bl" rotWithShape="0">
-              <a:srgbClr val="1E2761">
-                <a:alpha val="10000"/>
-              </a:srgbClr>
-            </a:outerShdw>
-          </a:effectLst>
-        </p:spPr>
-      </p:sp>
-      <p:sp>
-        <p:nvSpPr>
-          <p:cNvPr id="6" name="Shape 4"/>
-          <p:cNvSpPr/>
-          <p:nvPr/>
-        </p:nvSpPr>
-        <p:spPr>
-          <a:xfrm>
-            <a:off x="1604772" y="2834640"/>
-            <a:ext cx="585216" cy="585216"/>
-          </a:xfrm>
-          <a:prstGeom prst="ellipse">
-            <a:avLst/>
-          </a:prstGeom>
-          <a:solidFill>
-            <a:srgbClr val="3D8BFF"/>
-          </a:solidFill>
-          <a:ln/>
-        </p:spPr>
-      </p:sp>
-      <p:pic>
-        <p:nvPicPr>
-          <p:cNvPr id="7" name="Image 0" descr="./icons/file.png"/>
-          <p:cNvPicPr>
-            <a:picLocks noChangeAspect="1"/>
-          </p:cNvPicPr>
-          <p:nvPr/>
-        </p:nvPicPr>
-        <p:blipFill>
-          <a:blip r:embed="rId3"/>
-          <a:stretch>
-            <a:fillRect/>
-          </a:stretch>
-        </p:blipFill>
-        <p:spPr>
-          <a:xfrm>
-            <a:off x="1741932" y="2971800"/>
-            <a:ext cx="310896" cy="310896"/>
-          </a:xfrm>
-          <a:prstGeom prst="rect">
-            <a:avLst/>
-          </a:prstGeom>
-        </p:spPr>
-      </p:pic>
-      <p:sp>
-        <p:nvSpPr>
-          <p:cNvPr id="8" name="Text 5"/>
-          <p:cNvSpPr/>
-          <p:nvPr/>
-        </p:nvSpPr>
-        <p:spPr>
-          <a:xfrm>
-            <a:off x="822960" y="3611880"/>
-            <a:ext cx="2148840" cy="685800"/>
-          </a:xfrm>
-          <a:prstGeom prst="rect">
-            <a:avLst/>
-          </a:prstGeom>
-          <a:noFill/>
-          <a:ln/>
-        </p:spPr>
-        <p:txBody>
-          <a:bodyPr wrap="square" rtlCol="0" anchor="ctr"/>
-          <a:lstStyle/>
-          <a:p>
-            <a:pPr marL="0" indent="0" algn="ctr">
-              <a:lnSpc>
-                <a:spcPct val="110000"/>
-              </a:lnSpc>
-              <a:buNone/>
-            </a:pPr>
-            <a:r>
-              <a:rPr lang="en-US" sz="1600" b="1" dirty="0">
-                <a:solidFill>
-                  <a:srgbClr val="1E2761"/>
-                </a:solidFill>
-                <a:latin typeface="Cambria" pitchFamily="34" charset="0"/>
-                <a:ea typeface="Cambria" pitchFamily="34" charset="-122"/>
-                <a:cs typeface="Cambria" pitchFamily="34" charset="-120"/>
-              </a:rPr>
-              <a:t>Key-Value Extraction</a:t>
-            </a:r>
-            <a:endParaRPr lang="en-US" sz="1600" dirty="0"/>
-          </a:p>
-        </p:txBody>
-      </p:sp>
-      <p:sp>
-        <p:nvSpPr>
-          <p:cNvPr id="9" name="Text 6"/>
-          <p:cNvSpPr/>
-          <p:nvPr/>
-        </p:nvSpPr>
-        <p:spPr>
-          <a:xfrm>
-            <a:off x="868680" y="4297680"/>
-            <a:ext cx="2057400" cy="1005840"/>
-          </a:xfrm>
-          <a:prstGeom prst="rect">
-            <a:avLst/>
-          </a:prstGeom>
-          <a:noFill/>
-          <a:ln/>
-        </p:spPr>
-        <p:txBody>
-          <a:bodyPr wrap="square" rtlCol="0" anchor="ctr"/>
-          <a:lstStyle/>
-          <a:p>
-            <a:pPr marL="0" indent="0" algn="ctr">
-              <a:lnSpc>
-                <a:spcPct val="120000"/>
-              </a:lnSpc>
-              <a:buNone/>
-            </a:pPr>
-            <a:r>
-              <a:rPr lang="en-US" sz="1400" dirty="0">
-                <a:solidFill>
-                  <a:srgbClr val="5A6072"/>
-                </a:solidFill>
-                <a:latin typeface="Calibri" pitchFamily="34" charset="0"/>
-                <a:ea typeface="Calibri" pitchFamily="34" charset="-122"/>
-                <a:cs typeface="Calibri" pitchFamily="34" charset="-120"/>
-              </a:rPr>
-              <a:t>Maps unstructured layout fields to Pydantic models.</a:t>
-            </a:r>
-            <a:endParaRPr lang="en-US" sz="1400" dirty="0"/>
-          </a:p>
-        </p:txBody>
-      </p:sp>
-      <p:sp>
-        <p:nvSpPr>
-          <p:cNvPr id="10" name="Shape 7"/>
-          <p:cNvSpPr/>
-          <p:nvPr/>
-        </p:nvSpPr>
-        <p:spPr>
-          <a:xfrm>
-            <a:off x="3163824" y="3867912"/>
-            <a:ext cx="274320" cy="219456"/>
-          </a:xfrm>
-          <a:prstGeom prst="rightArrow">
-            <a:avLst/>
-          </a:prstGeom>
-          <a:solidFill>
-            <a:srgbClr val="3D8BFF"/>
-          </a:solidFill>
-          <a:ln/>
-        </p:spPr>
-      </p:sp>
-      <p:sp>
-        <p:nvSpPr>
-          <p:cNvPr id="11" name="Shape 8"/>
-          <p:cNvSpPr/>
-          <p:nvPr/>
-        </p:nvSpPr>
-        <p:spPr>
-          <a:xfrm>
-            <a:off x="4384548" y="1783080"/>
-            <a:ext cx="640080" cy="640080"/>
-          </a:xfrm>
-          <a:prstGeom prst="ellipse">
-            <a:avLst/>
-          </a:prstGeom>
-          <a:solidFill>
-            <a:srgbClr val="1E2761"/>
-          </a:solidFill>
-          <a:ln w="38100">
-            <a:solidFill>
-              <a:srgbClr val="FFFFFF"/>
-            </a:solidFill>
-            <a:prstDash val="solid"/>
-          </a:ln>
-        </p:spPr>
-      </p:sp>
-      <p:sp>
-        <p:nvSpPr>
-          <p:cNvPr id="12" name="Text 9"/>
-          <p:cNvSpPr/>
-          <p:nvPr/>
-        </p:nvSpPr>
-        <p:spPr>
-          <a:xfrm>
-            <a:off x="4384548" y="1783080"/>
-            <a:ext cx="640080" cy="640080"/>
-          </a:xfrm>
-          <a:prstGeom prst="rect">
-            <a:avLst/>
-          </a:prstGeom>
-          <a:noFill/>
-          <a:ln/>
-        </p:spPr>
-        <p:txBody>
-          <a:bodyPr wrap="square" rtlCol="0" anchor="ctr"/>
-          <a:lstStyle/>
-          <a:p>
-            <a:pPr marL="0" indent="0" algn="ctr">
-              <a:buNone/>
-            </a:pPr>
-            <a:r>
-              <a:rPr lang="en-US" sz="1800" b="1" dirty="0">
-                <a:solidFill>
-                  <a:srgbClr val="FFFFFF"/>
-                </a:solidFill>
-                <a:latin typeface="Cambria" pitchFamily="34" charset="0"/>
-                <a:ea typeface="Cambria" pitchFamily="34" charset="-122"/>
-                <a:cs typeface="Cambria" pitchFamily="34" charset="-120"/>
-              </a:rPr>
-              <a:t>2</a:t>
-            </a:r>
-            <a:endParaRPr lang="en-US" sz="1800" dirty="0"/>
-          </a:p>
-        </p:txBody>
-      </p:sp>
-      <p:sp>
-        <p:nvSpPr>
-          <p:cNvPr id="13" name="Shape 10"/>
-          <p:cNvSpPr/>
-          <p:nvPr/>
-        </p:nvSpPr>
-        <p:spPr>
-          <a:xfrm>
-            <a:off x="3493008" y="2560320"/>
-            <a:ext cx="2423160" cy="2834640"/>
-          </a:xfrm>
-          <a:prstGeom prst="roundRect">
-            <a:avLst>
-              <a:gd name="adj" fmla="val 3019"/>
-            </a:avLst>
-          </a:prstGeom>
-          <a:solidFill>
-            <a:srgbClr val="FFFFFF"/>
-          </a:solidFill>
-          <a:ln w="12700">
-            <a:solidFill>
-              <a:srgbClr val="DCE1F2"/>
-            </a:solidFill>
-            <a:prstDash val="solid"/>
-          </a:ln>
-          <a:effectLst>
-            <a:outerShdw blurRad="76200" dist="25400" dir="5400000" algn="bl" rotWithShape="0">
-              <a:srgbClr val="1E2761">
-                <a:alpha val="10000"/>
-              </a:srgbClr>
-            </a:outerShdw>
-          </a:effectLst>
-        </p:spPr>
-        <p:txBody>
-          <a:bodyPr/>
-          <a:lstStyle/>
-          <a:p>
-            <a:endParaRPr lang="en-IN" dirty="0"/>
-          </a:p>
-        </p:txBody>
-      </p:sp>
-      <p:sp>
-        <p:nvSpPr>
-          <p:cNvPr id="14" name="Shape 11"/>
-          <p:cNvSpPr/>
-          <p:nvPr/>
-        </p:nvSpPr>
-        <p:spPr>
-          <a:xfrm>
-            <a:off x="4411980" y="2834640"/>
-            <a:ext cx="585216" cy="585216"/>
-          </a:xfrm>
-          <a:prstGeom prst="ellipse">
-            <a:avLst/>
-          </a:prstGeom>
-          <a:solidFill>
-            <a:srgbClr val="3D8BFF"/>
-          </a:solidFill>
-          <a:ln/>
-        </p:spPr>
-      </p:sp>
-      <p:pic>
-        <p:nvPicPr>
-          <p:cNvPr id="15" name="Image 1" descr="./icons/refresh.png"/>
-          <p:cNvPicPr>
-            <a:picLocks noChangeAspect="1"/>
-          </p:cNvPicPr>
-          <p:nvPr/>
-        </p:nvPicPr>
-        <p:blipFill>
-          <a:blip r:embed="rId4"/>
-          <a:stretch>
-            <a:fillRect/>
-          </a:stretch>
-        </p:blipFill>
-        <p:spPr>
-          <a:xfrm>
-            <a:off x="4549140" y="2971800"/>
-            <a:ext cx="310896" cy="310896"/>
-          </a:xfrm>
-          <a:prstGeom prst="rect">
-            <a:avLst/>
-          </a:prstGeom>
-        </p:spPr>
-      </p:pic>
-      <p:sp>
-        <p:nvSpPr>
-          <p:cNvPr id="16" name="Text 12"/>
-          <p:cNvSpPr/>
-          <p:nvPr/>
-        </p:nvSpPr>
-        <p:spPr>
-          <a:xfrm>
-            <a:off x="3630168" y="3611880"/>
-            <a:ext cx="2148840" cy="685800"/>
-          </a:xfrm>
-          <a:prstGeom prst="rect">
-            <a:avLst/>
-          </a:prstGeom>
-          <a:noFill/>
-          <a:ln/>
-        </p:spPr>
-        <p:txBody>
-          <a:bodyPr wrap="square" rtlCol="0" anchor="ctr"/>
-          <a:lstStyle/>
-          <a:p>
-            <a:pPr marL="0" indent="0" algn="ctr">
-              <a:lnSpc>
-                <a:spcPct val="110000"/>
-              </a:lnSpc>
-              <a:buNone/>
-            </a:pPr>
-            <a:r>
-              <a:rPr lang="en-US" sz="1600" b="1" dirty="0">
-                <a:solidFill>
-                  <a:srgbClr val="1E2761"/>
-                </a:solidFill>
-                <a:latin typeface="Cambria" pitchFamily="34" charset="0"/>
-                <a:ea typeface="Cambria" pitchFamily="34" charset="-122"/>
-                <a:cs typeface="Cambria" pitchFamily="34" charset="-120"/>
-              </a:rPr>
-              <a:t>Fallback Parsing</a:t>
-            </a:r>
-            <a:endParaRPr lang="en-US" sz="1600" dirty="0"/>
-          </a:p>
-        </p:txBody>
-      </p:sp>
-      <p:sp>
-        <p:nvSpPr>
-          <p:cNvPr id="17" name="Text 13"/>
-          <p:cNvSpPr/>
-          <p:nvPr/>
-        </p:nvSpPr>
-        <p:spPr>
-          <a:xfrm>
-            <a:off x="3675888" y="4297680"/>
-            <a:ext cx="2057400" cy="1005840"/>
-          </a:xfrm>
-          <a:prstGeom prst="rect">
-            <a:avLst/>
-          </a:prstGeom>
-          <a:noFill/>
-          <a:ln/>
-        </p:spPr>
-        <p:txBody>
-          <a:bodyPr wrap="square" rtlCol="0" anchor="ctr"/>
-          <a:lstStyle/>
-          <a:p>
-            <a:pPr marL="0" indent="0" algn="ctr">
-              <a:lnSpc>
-                <a:spcPct val="120000"/>
-              </a:lnSpc>
-              <a:buNone/>
-            </a:pPr>
-            <a:r>
-              <a:rPr lang="en-US" sz="1400" dirty="0">
-                <a:solidFill>
-                  <a:srgbClr val="5A6072"/>
-                </a:solidFill>
-                <a:latin typeface="Calibri" pitchFamily="34" charset="0"/>
-                <a:ea typeface="Calibri" pitchFamily="34" charset="-122"/>
-                <a:cs typeface="Calibri" pitchFamily="34" charset="-120"/>
-              </a:rPr>
-              <a:t>PyPDF &amp; local regex fallback when cloud keys are offline.</a:t>
-            </a:r>
-            <a:endParaRPr lang="en-US" sz="1400" dirty="0"/>
-          </a:p>
-        </p:txBody>
-      </p:sp>
-      <p:sp>
-        <p:nvSpPr>
-          <p:cNvPr id="18" name="Shape 14"/>
-          <p:cNvSpPr/>
-          <p:nvPr/>
-        </p:nvSpPr>
-        <p:spPr>
-          <a:xfrm>
-            <a:off x="5971032" y="3867912"/>
-            <a:ext cx="274320" cy="219456"/>
-          </a:xfrm>
-          <a:prstGeom prst="rightArrow">
-            <a:avLst/>
-          </a:prstGeom>
-          <a:solidFill>
-            <a:srgbClr val="3D8BFF"/>
-          </a:solidFill>
-          <a:ln/>
-        </p:spPr>
-      </p:sp>
-      <p:sp>
-        <p:nvSpPr>
-          <p:cNvPr id="19" name="Shape 15"/>
-          <p:cNvSpPr/>
-          <p:nvPr/>
-        </p:nvSpPr>
-        <p:spPr>
-          <a:xfrm>
-            <a:off x="7191756" y="1783080"/>
-            <a:ext cx="640080" cy="640080"/>
-          </a:xfrm>
-          <a:prstGeom prst="ellipse">
-            <a:avLst/>
-          </a:prstGeom>
-          <a:solidFill>
-            <a:srgbClr val="1E2761"/>
-          </a:solidFill>
-          <a:ln w="38100">
-            <a:solidFill>
-              <a:srgbClr val="FFFFFF"/>
-            </a:solidFill>
-            <a:prstDash val="solid"/>
-          </a:ln>
-        </p:spPr>
-      </p:sp>
-      <p:sp>
-        <p:nvSpPr>
-          <p:cNvPr id="20" name="Text 16"/>
-          <p:cNvSpPr/>
-          <p:nvPr/>
-        </p:nvSpPr>
-        <p:spPr>
-          <a:xfrm>
-            <a:off x="7191756" y="1783080"/>
-            <a:ext cx="640080" cy="640080"/>
-          </a:xfrm>
-          <a:prstGeom prst="rect">
-            <a:avLst/>
-          </a:prstGeom>
-          <a:noFill/>
-          <a:ln/>
-        </p:spPr>
-        <p:txBody>
-          <a:bodyPr wrap="square" rtlCol="0" anchor="ctr"/>
-          <a:lstStyle/>
-          <a:p>
-            <a:pPr marL="0" indent="0" algn="ctr">
-              <a:buNone/>
-            </a:pPr>
-            <a:r>
-              <a:rPr lang="en-US" sz="1800" b="1" dirty="0">
-                <a:solidFill>
-                  <a:srgbClr val="FFFFFF"/>
-                </a:solidFill>
-                <a:latin typeface="Cambria" pitchFamily="34" charset="0"/>
-                <a:ea typeface="Cambria" pitchFamily="34" charset="-122"/>
-                <a:cs typeface="Cambria" pitchFamily="34" charset="-120"/>
-              </a:rPr>
-              <a:t>3</a:t>
-            </a:r>
-            <a:endParaRPr lang="en-US" sz="1800" dirty="0"/>
-          </a:p>
-        </p:txBody>
-      </p:sp>
-      <p:sp>
-        <p:nvSpPr>
-          <p:cNvPr id="21" name="Shape 17"/>
-          <p:cNvSpPr/>
-          <p:nvPr/>
-        </p:nvSpPr>
-        <p:spPr>
-          <a:xfrm>
-            <a:off x="6300216" y="2560320"/>
-            <a:ext cx="2423160" cy="2834640"/>
-          </a:xfrm>
-          <a:prstGeom prst="roundRect">
-            <a:avLst>
-              <a:gd name="adj" fmla="val 3019"/>
-            </a:avLst>
-          </a:prstGeom>
-          <a:solidFill>
-            <a:srgbClr val="FFFFFF"/>
-          </a:solidFill>
-          <a:ln w="12700">
-            <a:solidFill>
-              <a:srgbClr val="DCE1F2"/>
-            </a:solidFill>
-            <a:prstDash val="solid"/>
-          </a:ln>
-          <a:effectLst>
-            <a:outerShdw blurRad="76200" dist="25400" dir="5400000" algn="bl" rotWithShape="0">
-              <a:srgbClr val="1E2761">
-                <a:alpha val="10000"/>
-              </a:srgbClr>
-            </a:outerShdw>
-          </a:effectLst>
-        </p:spPr>
-      </p:sp>
-      <p:sp>
-        <p:nvSpPr>
-          <p:cNvPr id="22" name="Shape 18"/>
-          <p:cNvSpPr/>
-          <p:nvPr/>
-        </p:nvSpPr>
-        <p:spPr>
-          <a:xfrm>
-            <a:off x="7219188" y="2834640"/>
-            <a:ext cx="585216" cy="585216"/>
-          </a:xfrm>
-          <a:prstGeom prst="ellipse">
-            <a:avLst/>
-          </a:prstGeom>
-          <a:solidFill>
-            <a:srgbClr val="3D8BFF"/>
-          </a:solidFill>
-          <a:ln/>
-        </p:spPr>
-      </p:sp>
-      <p:pic>
-        <p:nvPicPr>
-          <p:cNvPr id="23" name="Image 2" descr="./icons/cpu.png"/>
-          <p:cNvPicPr>
-            <a:picLocks noChangeAspect="1"/>
-          </p:cNvPicPr>
-          <p:nvPr/>
-        </p:nvPicPr>
-        <p:blipFill>
-          <a:blip r:embed="rId5"/>
-          <a:stretch>
-            <a:fillRect/>
-          </a:stretch>
-        </p:blipFill>
-        <p:spPr>
-          <a:xfrm>
-            <a:off x="7356348" y="2971800"/>
-            <a:ext cx="310896" cy="310896"/>
-          </a:xfrm>
-          <a:prstGeom prst="rect">
-            <a:avLst/>
-          </a:prstGeom>
-        </p:spPr>
-      </p:pic>
-      <p:sp>
-        <p:nvSpPr>
-          <p:cNvPr id="24" name="Text 19"/>
-          <p:cNvSpPr/>
-          <p:nvPr/>
-        </p:nvSpPr>
-        <p:spPr>
-          <a:xfrm>
-            <a:off x="6437376" y="3611880"/>
-            <a:ext cx="2148840" cy="685800"/>
-          </a:xfrm>
-          <a:prstGeom prst="rect">
-            <a:avLst/>
-          </a:prstGeom>
-          <a:noFill/>
-          <a:ln/>
-        </p:spPr>
-        <p:txBody>
-          <a:bodyPr wrap="square" rtlCol="0" anchor="ctr"/>
-          <a:lstStyle/>
-          <a:p>
-            <a:pPr marL="0" indent="0" algn="ctr">
-              <a:lnSpc>
-                <a:spcPct val="110000"/>
-              </a:lnSpc>
-              <a:buNone/>
-            </a:pPr>
-            <a:r>
-              <a:rPr lang="en-US" sz="1600" b="1" dirty="0">
-                <a:solidFill>
-                  <a:srgbClr val="1E2761"/>
-                </a:solidFill>
-                <a:latin typeface="Cambria" pitchFamily="34" charset="0"/>
-                <a:ea typeface="Cambria" pitchFamily="34" charset="-122"/>
-                <a:cs typeface="Cambria" pitchFamily="34" charset="-120"/>
-              </a:rPr>
-              <a:t>Vector Embedding</a:t>
-            </a:r>
-            <a:endParaRPr lang="en-US" sz="1600" dirty="0"/>
-          </a:p>
-        </p:txBody>
-      </p:sp>
-      <p:sp>
-        <p:nvSpPr>
-          <p:cNvPr id="25" name="Text 20"/>
-          <p:cNvSpPr/>
-          <p:nvPr/>
-        </p:nvSpPr>
-        <p:spPr>
-          <a:xfrm>
-            <a:off x="6483096" y="4297680"/>
-            <a:ext cx="2057400" cy="1005840"/>
-          </a:xfrm>
-          <a:prstGeom prst="rect">
-            <a:avLst/>
-          </a:prstGeom>
-          <a:noFill/>
-          <a:ln/>
-        </p:spPr>
-        <p:txBody>
-          <a:bodyPr wrap="square" rtlCol="0" anchor="ctr"/>
-          <a:lstStyle/>
-          <a:p>
-            <a:pPr marL="0" indent="0" algn="ctr">
-              <a:lnSpc>
-                <a:spcPct val="120000"/>
-              </a:lnSpc>
-              <a:buNone/>
-            </a:pPr>
-            <a:r>
-              <a:rPr lang="en-US" sz="1400" dirty="0">
-                <a:solidFill>
-                  <a:srgbClr val="5A6072"/>
-                </a:solidFill>
-                <a:latin typeface="Calibri" pitchFamily="34" charset="0"/>
-                <a:ea typeface="Calibri" pitchFamily="34" charset="-122"/>
-                <a:cs typeface="Calibri" pitchFamily="34" charset="-120"/>
-              </a:rPr>
-              <a:t>Encodes text chunks into dense 384-d vectors using all-MiniLM-L6-v2.</a:t>
-            </a:r>
-            <a:endParaRPr lang="en-US" sz="1400" dirty="0"/>
-          </a:p>
-        </p:txBody>
-      </p:sp>
-      <p:sp>
-        <p:nvSpPr>
-          <p:cNvPr id="26" name="Shape 21"/>
-          <p:cNvSpPr/>
-          <p:nvPr/>
-        </p:nvSpPr>
-        <p:spPr>
-          <a:xfrm>
-            <a:off x="8778240" y="3867912"/>
-            <a:ext cx="274320" cy="219456"/>
-          </a:xfrm>
-          <a:prstGeom prst="rightArrow">
-            <a:avLst/>
-          </a:prstGeom>
-          <a:solidFill>
-            <a:srgbClr val="3D8BFF"/>
-          </a:solidFill>
-          <a:ln/>
-        </p:spPr>
-      </p:sp>
-      <p:sp>
-        <p:nvSpPr>
-          <p:cNvPr id="27" name="Shape 22"/>
-          <p:cNvSpPr/>
-          <p:nvPr/>
-        </p:nvSpPr>
-        <p:spPr>
-          <a:xfrm>
-            <a:off x="9998964" y="1783080"/>
-            <a:ext cx="640080" cy="640080"/>
-          </a:xfrm>
-          <a:prstGeom prst="ellipse">
-            <a:avLst/>
-          </a:prstGeom>
-          <a:solidFill>
-            <a:srgbClr val="1E2761"/>
-          </a:solidFill>
-          <a:ln w="38100">
-            <a:solidFill>
-              <a:srgbClr val="FFFFFF"/>
-            </a:solidFill>
-            <a:prstDash val="solid"/>
-          </a:ln>
-        </p:spPr>
-      </p:sp>
-      <p:sp>
-        <p:nvSpPr>
-          <p:cNvPr id="28" name="Text 23"/>
-          <p:cNvSpPr/>
-          <p:nvPr/>
-        </p:nvSpPr>
-        <p:spPr>
-          <a:xfrm>
-            <a:off x="9998964" y="1783080"/>
-            <a:ext cx="640080" cy="640080"/>
-          </a:xfrm>
-          <a:prstGeom prst="rect">
-            <a:avLst/>
-          </a:prstGeom>
-          <a:noFill/>
-          <a:ln/>
-        </p:spPr>
-        <p:txBody>
-          <a:bodyPr wrap="square" rtlCol="0" anchor="ctr"/>
-          <a:lstStyle/>
-          <a:p>
-            <a:pPr marL="0" indent="0" algn="ctr">
-              <a:buNone/>
-            </a:pPr>
-            <a:r>
-              <a:rPr lang="en-US" sz="1800" b="1" dirty="0">
-                <a:solidFill>
-                  <a:srgbClr val="FFFFFF"/>
-                </a:solidFill>
-                <a:latin typeface="Cambria" pitchFamily="34" charset="0"/>
-                <a:ea typeface="Cambria" pitchFamily="34" charset="-122"/>
-                <a:cs typeface="Cambria" pitchFamily="34" charset="-120"/>
-              </a:rPr>
-              <a:t>4</a:t>
-            </a:r>
-            <a:endParaRPr lang="en-US" sz="1800" dirty="0"/>
-          </a:p>
-        </p:txBody>
-      </p:sp>
-      <p:sp>
-        <p:nvSpPr>
-          <p:cNvPr id="29" name="Shape 24"/>
-          <p:cNvSpPr/>
-          <p:nvPr/>
-        </p:nvSpPr>
-        <p:spPr>
-          <a:xfrm>
-            <a:off x="9107424" y="2560320"/>
-            <a:ext cx="2423160" cy="2834640"/>
-          </a:xfrm>
-          <a:prstGeom prst="roundRect">
-            <a:avLst>
-              <a:gd name="adj" fmla="val 3019"/>
-            </a:avLst>
-          </a:prstGeom>
-          <a:solidFill>
-            <a:srgbClr val="FFFFFF"/>
-          </a:solidFill>
-          <a:ln w="12700">
-            <a:solidFill>
-              <a:srgbClr val="DCE1F2"/>
-            </a:solidFill>
-            <a:prstDash val="solid"/>
-          </a:ln>
-          <a:effectLst>
-            <a:outerShdw blurRad="76200" dist="25400" dir="5400000" algn="bl" rotWithShape="0">
-              <a:srgbClr val="1E2761">
-                <a:alpha val="10000"/>
-              </a:srgbClr>
-            </a:outerShdw>
-          </a:effectLst>
-        </p:spPr>
-      </p:sp>
-      <p:sp>
-        <p:nvSpPr>
-          <p:cNvPr id="30" name="Shape 25"/>
-          <p:cNvSpPr/>
-          <p:nvPr/>
-        </p:nvSpPr>
-        <p:spPr>
-          <a:xfrm>
-            <a:off x="10026396" y="2834640"/>
-            <a:ext cx="585216" cy="585216"/>
-          </a:xfrm>
-          <a:prstGeom prst="ellipse">
-            <a:avLst/>
-          </a:prstGeom>
-          <a:solidFill>
-            <a:srgbClr val="3D8BFF"/>
-          </a:solidFill>
-          <a:ln/>
-        </p:spPr>
-      </p:sp>
-      <p:pic>
-        <p:nvPicPr>
-          <p:cNvPr id="31" name="Image 3" descr="./icons/search.png"/>
-          <p:cNvPicPr>
-            <a:picLocks noChangeAspect="1"/>
-          </p:cNvPicPr>
-          <p:nvPr/>
-        </p:nvPicPr>
-        <p:blipFill>
-          <a:blip r:embed="rId6"/>
-          <a:stretch>
-            <a:fillRect/>
-          </a:stretch>
-        </p:blipFill>
-        <p:spPr>
-          <a:xfrm>
-            <a:off x="10163556" y="2971800"/>
-            <a:ext cx="310896" cy="310896"/>
-          </a:xfrm>
-          <a:prstGeom prst="rect">
-            <a:avLst/>
-          </a:prstGeom>
-        </p:spPr>
-      </p:pic>
-      <p:sp>
-        <p:nvSpPr>
-          <p:cNvPr id="32" name="Text 26"/>
-          <p:cNvSpPr/>
-          <p:nvPr/>
-        </p:nvSpPr>
-        <p:spPr>
-          <a:xfrm>
-            <a:off x="9244584" y="3611880"/>
-            <a:ext cx="2148840" cy="685800"/>
-          </a:xfrm>
-          <a:prstGeom prst="rect">
-            <a:avLst/>
-          </a:prstGeom>
-          <a:noFill/>
-          <a:ln/>
-        </p:spPr>
-        <p:txBody>
-          <a:bodyPr wrap="square" rtlCol="0" anchor="ctr"/>
-          <a:lstStyle/>
-          <a:p>
-            <a:pPr marL="0" indent="0" algn="ctr">
-              <a:lnSpc>
-                <a:spcPct val="110000"/>
-              </a:lnSpc>
-              <a:buNone/>
-            </a:pPr>
-            <a:r>
-              <a:rPr lang="en-US" sz="1600" b="1" dirty="0">
-                <a:solidFill>
-                  <a:srgbClr val="1E2761"/>
-                </a:solidFill>
-                <a:latin typeface="Cambria" pitchFamily="34" charset="0"/>
-                <a:ea typeface="Cambria" pitchFamily="34" charset="-122"/>
-                <a:cs typeface="Cambria" pitchFamily="34" charset="-120"/>
-              </a:rPr>
-              <a:t>Similarity Search</a:t>
-            </a:r>
-            <a:endParaRPr lang="en-US" sz="1600" dirty="0"/>
-          </a:p>
-        </p:txBody>
-      </p:sp>
-      <p:sp>
-        <p:nvSpPr>
-          <p:cNvPr id="33" name="Text 27"/>
-          <p:cNvSpPr/>
-          <p:nvPr/>
-        </p:nvSpPr>
-        <p:spPr>
-          <a:xfrm>
-            <a:off x="9290304" y="4297680"/>
-            <a:ext cx="2057400" cy="1005840"/>
-          </a:xfrm>
-          <a:prstGeom prst="rect">
-            <a:avLst/>
-          </a:prstGeom>
-          <a:noFill/>
-          <a:ln/>
-        </p:spPr>
-        <p:txBody>
-          <a:bodyPr wrap="square" rtlCol="0" anchor="ctr"/>
-          <a:lstStyle/>
-          <a:p>
-            <a:pPr marL="0" indent="0" algn="ctr">
-              <a:lnSpc>
-                <a:spcPct val="120000"/>
-              </a:lnSpc>
-              <a:buNone/>
-            </a:pPr>
-            <a:r>
-              <a:rPr lang="en-US" sz="1400" dirty="0">
-                <a:solidFill>
-                  <a:srgbClr val="5A6072"/>
-                </a:solidFill>
-                <a:latin typeface="Calibri" pitchFamily="34" charset="0"/>
-                <a:ea typeface="Calibri" pitchFamily="34" charset="-122"/>
-                <a:cs typeface="Calibri" pitchFamily="34" charset="-120"/>
-              </a:rPr>
-              <a:t>Performs Cosine Distance calculation over Qdrant collections.</a:t>
-            </a:r>
-            <a:endParaRPr lang="en-US" sz="1400" dirty="0"/>
-          </a:p>
-        </p:txBody>
-      </p:sp>
-      <p:sp>
-        <p:nvSpPr>
-          <p:cNvPr id="34" name="Text 28"/>
-          <p:cNvSpPr/>
-          <p:nvPr/>
-        </p:nvSpPr>
-        <p:spPr>
-          <a:xfrm>
-            <a:off x="457200" y="6565392"/>
-            <a:ext cx="8229600" cy="274320"/>
-          </a:xfrm>
-          <a:prstGeom prst="rect">
-            <a:avLst/>
-          </a:prstGeom>
-          <a:noFill/>
-          <a:ln/>
-        </p:spPr>
-        <p:txBody>
-          <a:bodyPr wrap="square" rtlCol="0" anchor="ctr"/>
-          <a:lstStyle/>
-          <a:p>
-            <a:pPr marL="0" indent="0" algn="l">
-              <a:buNone/>
-            </a:pPr>
-            <a:r>
-              <a:rPr lang="en-US" sz="900" dirty="0">
-                <a:solidFill>
-                  <a:srgbClr val="8A90A6"/>
-                </a:solidFill>
-                <a:latin typeface="Calibri" pitchFamily="34" charset="0"/>
-                <a:ea typeface="Calibri" pitchFamily="34" charset="-122"/>
-                <a:cs typeface="Calibri" pitchFamily="34" charset="-120"/>
-              </a:rPr>
-              <a:t>Intelligent Invoice Processing &amp; Semantic Search Engine</a:t>
-            </a:r>
-            <a:endParaRPr lang="en-US" sz="900" dirty="0"/>
-          </a:p>
-        </p:txBody>
-      </p:sp>
-      <p:sp>
-        <p:nvSpPr>
-          <p:cNvPr id="35" name="Text 29"/>
-          <p:cNvSpPr/>
-          <p:nvPr/>
-        </p:nvSpPr>
-        <p:spPr>
-          <a:xfrm>
-            <a:off x="11521440" y="6565392"/>
-            <a:ext cx="457200" cy="274320"/>
-          </a:xfrm>
-          <a:prstGeom prst="rect">
-            <a:avLst/>
-          </a:prstGeom>
-          <a:noFill/>
-          <a:ln/>
-        </p:spPr>
-        <p:txBody>
-          <a:bodyPr wrap="square" rtlCol="0" anchor="ctr"/>
-          <a:lstStyle/>
-          <a:p>
-            <a:pPr marL="0" indent="0" algn="r">
-              <a:buNone/>
-            </a:pPr>
-            <a:r>
-              <a:rPr lang="en-US" sz="900" dirty="0">
-                <a:solidFill>
-                  <a:srgbClr val="8A90A6"/>
-                </a:solidFill>
-                <a:latin typeface="Calibri" pitchFamily="34" charset="0"/>
-                <a:ea typeface="Calibri" pitchFamily="34" charset="-122"/>
-                <a:cs typeface="Calibri" pitchFamily="34" charset="-120"/>
-              </a:rPr>
-              <a:t>8</a:t>
-            </a:r>
-            <a:endParaRPr lang="en-US" sz="900" dirty="0"/>
-          </a:p>
-        </p:txBody>
-      </p:sp>
-    </p:spTree>
-  </p:cSld>
-  <p:clrMapOvr>
-    <a:masterClrMapping/>
-  </p:clrMapOvr>
-</p:sld>
-</file>
-
-<file path=ppt/slides/slide9.xml><?xml version="1.0" encoding="utf-8"?>
-<p:sld xmlns:a="http://schemas.openxmlformats.org/drawingml/2006/main" xmlns:r="http://schemas.openxmlformats.org/officeDocument/2006/relationships" xmlns:p="http://schemas.openxmlformats.org/presentationml/2006/main">
   <p:cSld name="Slide 9">
     <p:bg>
       <p:bgPr>
@@ -11769,8 +9984,504 @@
         </p:blipFill>
         <p:spPr>
           <a:xfrm>
-            <a:off x="336752" y="1668780"/>
+            <a:off x="341633" y="1668780"/>
             <a:ext cx="6339946" cy="4288221"/>
+          </a:xfrm>
+          <a:prstGeom prst="rect">
+            <a:avLst/>
+          </a:prstGeom>
+        </p:spPr>
+      </p:pic>
+    </p:spTree>
+  </p:cSld>
+  <p:clrMapOvr>
+    <a:masterClrMapping/>
+  </p:clrMapOvr>
+</p:sld>
+</file>
+
+<file path=ppt/slides/slide9.xml><?xml version="1.0" encoding="utf-8"?>
+<p:sld xmlns:a="http://schemas.openxmlformats.org/drawingml/2006/main" xmlns:r="http://schemas.openxmlformats.org/officeDocument/2006/relationships" xmlns:p="http://schemas.openxmlformats.org/presentationml/2006/main">
+  <p:cSld name="Slide 10">
+    <p:bg>
+      <p:bgPr>
+        <a:solidFill>
+          <a:srgbClr val="FFFFFF"/>
+        </a:solidFill>
+        <a:effectLst/>
+      </p:bgPr>
+    </p:bg>
+    <p:spTree>
+      <p:nvGrpSpPr>
+        <p:cNvPr id="1" name=""/>
+        <p:cNvGrpSpPr/>
+        <p:nvPr/>
+      </p:nvGrpSpPr>
+      <p:grpSpPr>
+        <a:xfrm>
+          <a:off x="0" y="0"/>
+          <a:ext cx="0" cy="0"/>
+          <a:chOff x="0" y="0"/>
+          <a:chExt cx="0" cy="0"/>
+        </a:xfrm>
+      </p:grpSpPr>
+      <p:sp>
+        <p:nvSpPr>
+          <p:cNvPr id="2" name="Text 0"/>
+          <p:cNvSpPr/>
+          <p:nvPr/>
+        </p:nvSpPr>
+        <p:spPr>
+          <a:xfrm>
+            <a:off x="548640" y="384048"/>
+            <a:ext cx="11064240" cy="640080"/>
+          </a:xfrm>
+          <a:prstGeom prst="rect">
+            <a:avLst/>
+          </a:prstGeom>
+          <a:noFill/>
+          <a:ln/>
+        </p:spPr>
+        <p:txBody>
+          <a:bodyPr wrap="square" rtlCol="0" anchor="ctr"/>
+          <a:lstStyle/>
+          <a:p>
+            <a:pPr marL="0" indent="0" algn="l">
+              <a:buNone/>
+            </a:pPr>
+            <a:r>
+              <a:rPr lang="en-US" sz="3000" b="1" dirty="0">
+                <a:solidFill>
+                  <a:srgbClr val="1E2761"/>
+                </a:solidFill>
+                <a:latin typeface="Cambria" pitchFamily="34" charset="0"/>
+                <a:ea typeface="Cambria" pitchFamily="34" charset="-122"/>
+                <a:cs typeface="Cambria" pitchFamily="34" charset="-120"/>
+              </a:rPr>
+              <a:t>Development Methodology &amp; Verification</a:t>
+            </a:r>
+            <a:endParaRPr lang="en-US" sz="3000" dirty="0"/>
+          </a:p>
+        </p:txBody>
+      </p:sp>
+      <p:sp>
+        <p:nvSpPr>
+          <p:cNvPr id="3" name="Shape 1"/>
+          <p:cNvSpPr/>
+          <p:nvPr/>
+        </p:nvSpPr>
+        <p:spPr>
+          <a:xfrm>
+            <a:off x="644810" y="1122663"/>
+            <a:ext cx="2829910" cy="1163337"/>
+          </a:xfrm>
+          <a:prstGeom prst="roundRect">
+            <a:avLst>
+              <a:gd name="adj" fmla="val 2778"/>
+            </a:avLst>
+          </a:prstGeom>
+          <a:solidFill>
+            <a:srgbClr val="F7F8FC"/>
+          </a:solidFill>
+          <a:ln/>
+        </p:spPr>
+      </p:sp>
+      <p:sp>
+        <p:nvSpPr>
+          <p:cNvPr id="6" name="Text 3"/>
+          <p:cNvSpPr/>
+          <p:nvPr/>
+        </p:nvSpPr>
+        <p:spPr>
+          <a:xfrm>
+            <a:off x="613910" y="1122664"/>
+            <a:ext cx="3017520" cy="594360"/>
+          </a:xfrm>
+          <a:prstGeom prst="rect">
+            <a:avLst/>
+          </a:prstGeom>
+          <a:noFill/>
+          <a:ln/>
+        </p:spPr>
+        <p:txBody>
+          <a:bodyPr wrap="square" rtlCol="0" anchor="ctr"/>
+          <a:lstStyle/>
+          <a:p>
+            <a:pPr marL="0" indent="0" algn="ctr">
+              <a:buNone/>
+            </a:pPr>
+            <a:r>
+              <a:rPr lang="en-US" b="1" dirty="0">
+                <a:solidFill>
+                  <a:srgbClr val="1E2761"/>
+                </a:solidFill>
+                <a:latin typeface="Cambria" pitchFamily="34" charset="0"/>
+                <a:ea typeface="Cambria" pitchFamily="34" charset="-122"/>
+                <a:cs typeface="Cambria" pitchFamily="34" charset="-120"/>
+              </a:rPr>
+              <a:t>Agile Architecture</a:t>
+            </a:r>
+            <a:endParaRPr lang="en-US" dirty="0"/>
+          </a:p>
+        </p:txBody>
+      </p:sp>
+      <p:sp>
+        <p:nvSpPr>
+          <p:cNvPr id="7" name="Text 4"/>
+          <p:cNvSpPr/>
+          <p:nvPr/>
+        </p:nvSpPr>
+        <p:spPr>
+          <a:xfrm>
+            <a:off x="613910" y="1298450"/>
+            <a:ext cx="2926080" cy="1097280"/>
+          </a:xfrm>
+          <a:prstGeom prst="rect">
+            <a:avLst/>
+          </a:prstGeom>
+          <a:noFill/>
+          <a:ln/>
+        </p:spPr>
+        <p:txBody>
+          <a:bodyPr wrap="square" rtlCol="0" anchor="ctr"/>
+          <a:lstStyle/>
+          <a:p>
+            <a:pPr marL="0" indent="0" algn="ctr">
+              <a:lnSpc>
+                <a:spcPct val="125000"/>
+              </a:lnSpc>
+              <a:buNone/>
+            </a:pPr>
+            <a:r>
+              <a:rPr lang="en-US" sz="1600" dirty="0">
+                <a:solidFill>
+                  <a:srgbClr val="5A6072"/>
+                </a:solidFill>
+                <a:latin typeface="Calibri" pitchFamily="34" charset="0"/>
+                <a:ea typeface="Calibri" pitchFamily="34" charset="-122"/>
+                <a:cs typeface="Calibri" pitchFamily="34" charset="-120"/>
+              </a:rPr>
+              <a:t>Component-driven development with decoupled microservices.</a:t>
+            </a:r>
+            <a:endParaRPr lang="en-US" sz="1600" dirty="0"/>
+          </a:p>
+        </p:txBody>
+      </p:sp>
+      <p:sp>
+        <p:nvSpPr>
+          <p:cNvPr id="8" name="Shape 5"/>
+          <p:cNvSpPr/>
+          <p:nvPr/>
+        </p:nvSpPr>
+        <p:spPr>
+          <a:xfrm>
+            <a:off x="643233" y="2628900"/>
+            <a:ext cx="2831487" cy="1440180"/>
+          </a:xfrm>
+          <a:prstGeom prst="roundRect">
+            <a:avLst>
+              <a:gd name="adj" fmla="val 2778"/>
+            </a:avLst>
+          </a:prstGeom>
+          <a:solidFill>
+            <a:srgbClr val="F7F8FC"/>
+          </a:solidFill>
+          <a:ln/>
+        </p:spPr>
+      </p:sp>
+      <p:sp>
+        <p:nvSpPr>
+          <p:cNvPr id="11" name="Text 7"/>
+          <p:cNvSpPr/>
+          <p:nvPr/>
+        </p:nvSpPr>
+        <p:spPr>
+          <a:xfrm>
+            <a:off x="548640" y="2583180"/>
+            <a:ext cx="3017520" cy="594360"/>
+          </a:xfrm>
+          <a:prstGeom prst="rect">
+            <a:avLst/>
+          </a:prstGeom>
+          <a:noFill/>
+          <a:ln/>
+        </p:spPr>
+        <p:txBody>
+          <a:bodyPr wrap="square" rtlCol="0" anchor="ctr"/>
+          <a:lstStyle/>
+          <a:p>
+            <a:pPr marL="0" indent="0" algn="ctr">
+              <a:buNone/>
+            </a:pPr>
+            <a:r>
+              <a:rPr lang="en-US" b="1" dirty="0">
+                <a:solidFill>
+                  <a:srgbClr val="1E2761"/>
+                </a:solidFill>
+                <a:latin typeface="Cambria" pitchFamily="34" charset="0"/>
+                <a:ea typeface="Cambria" pitchFamily="34" charset="-122"/>
+                <a:cs typeface="Cambria" pitchFamily="34" charset="-120"/>
+              </a:rPr>
+              <a:t>AI-Assisted Prototyping</a:t>
+            </a:r>
+            <a:endParaRPr lang="en-US" dirty="0"/>
+          </a:p>
+        </p:txBody>
+      </p:sp>
+      <p:sp>
+        <p:nvSpPr>
+          <p:cNvPr id="12" name="Text 8"/>
+          <p:cNvSpPr/>
+          <p:nvPr/>
+        </p:nvSpPr>
+        <p:spPr>
+          <a:xfrm>
+            <a:off x="548640" y="2971800"/>
+            <a:ext cx="2926080" cy="1097280"/>
+          </a:xfrm>
+          <a:prstGeom prst="rect">
+            <a:avLst/>
+          </a:prstGeom>
+          <a:noFill/>
+          <a:ln/>
+        </p:spPr>
+        <p:txBody>
+          <a:bodyPr wrap="square" rtlCol="0" anchor="ctr"/>
+          <a:lstStyle/>
+          <a:p>
+            <a:pPr marL="0" indent="0" algn="ctr">
+              <a:lnSpc>
+                <a:spcPct val="125000"/>
+              </a:lnSpc>
+              <a:buNone/>
+            </a:pPr>
+            <a:r>
+              <a:rPr lang="en-US" sz="1600" dirty="0">
+                <a:solidFill>
+                  <a:srgbClr val="5A6072"/>
+                </a:solidFill>
+                <a:latin typeface="Calibri" pitchFamily="34" charset="0"/>
+                <a:ea typeface="Calibri" pitchFamily="34" charset="-122"/>
+                <a:cs typeface="Calibri" pitchFamily="34" charset="-120"/>
+              </a:rPr>
+              <a:t>Accelerated schema design, FastAPI route setup, and container orchestration.</a:t>
+            </a:r>
+            <a:endParaRPr lang="en-US" sz="1600" dirty="0"/>
+          </a:p>
+        </p:txBody>
+      </p:sp>
+      <p:sp>
+        <p:nvSpPr>
+          <p:cNvPr id="13" name="Shape 9"/>
+          <p:cNvSpPr/>
+          <p:nvPr/>
+        </p:nvSpPr>
+        <p:spPr>
+          <a:xfrm>
+            <a:off x="643232" y="4274820"/>
+            <a:ext cx="2831488" cy="1783080"/>
+          </a:xfrm>
+          <a:prstGeom prst="roundRect">
+            <a:avLst>
+              <a:gd name="adj" fmla="val 2778"/>
+            </a:avLst>
+          </a:prstGeom>
+          <a:solidFill>
+            <a:srgbClr val="F7F8FC"/>
+          </a:solidFill>
+          <a:ln/>
+        </p:spPr>
+        <p:txBody>
+          <a:bodyPr/>
+          <a:lstStyle/>
+          <a:p>
+            <a:endParaRPr lang="en-IN" dirty="0"/>
+          </a:p>
+        </p:txBody>
+      </p:sp>
+      <p:sp>
+        <p:nvSpPr>
+          <p:cNvPr id="16" name="Text 11"/>
+          <p:cNvSpPr/>
+          <p:nvPr/>
+        </p:nvSpPr>
+        <p:spPr>
+          <a:xfrm>
+            <a:off x="435127" y="4229100"/>
+            <a:ext cx="3139295" cy="594360"/>
+          </a:xfrm>
+          <a:prstGeom prst="rect">
+            <a:avLst/>
+          </a:prstGeom>
+          <a:noFill/>
+          <a:ln/>
+        </p:spPr>
+        <p:txBody>
+          <a:bodyPr wrap="square" rtlCol="0" anchor="ctr"/>
+          <a:lstStyle/>
+          <a:p>
+            <a:pPr marL="0" indent="0" algn="ctr">
+              <a:buNone/>
+            </a:pPr>
+            <a:r>
+              <a:rPr lang="en-US" b="1" dirty="0">
+                <a:solidFill>
+                  <a:srgbClr val="1E2761"/>
+                </a:solidFill>
+                <a:latin typeface="Cambria" pitchFamily="34" charset="0"/>
+                <a:ea typeface="Cambria" pitchFamily="34" charset="-122"/>
+                <a:cs typeface="Cambria" pitchFamily="34" charset="-120"/>
+              </a:rPr>
+              <a:t>  Verification &amp; Testing</a:t>
+            </a:r>
+            <a:endParaRPr lang="en-US" dirty="0"/>
+          </a:p>
+        </p:txBody>
+      </p:sp>
+      <p:sp>
+        <p:nvSpPr>
+          <p:cNvPr id="17" name="Text 12"/>
+          <p:cNvSpPr/>
+          <p:nvPr/>
+        </p:nvSpPr>
+        <p:spPr>
+          <a:xfrm>
+            <a:off x="480847" y="4823460"/>
+            <a:ext cx="3044165" cy="1097280"/>
+          </a:xfrm>
+          <a:prstGeom prst="rect">
+            <a:avLst/>
+          </a:prstGeom>
+          <a:noFill/>
+          <a:ln/>
+        </p:spPr>
+        <p:txBody>
+          <a:bodyPr wrap="square" rtlCol="0" anchor="ctr"/>
+          <a:lstStyle/>
+          <a:p>
+            <a:pPr marL="0" indent="0" algn="ctr">
+              <a:lnSpc>
+                <a:spcPct val="125000"/>
+              </a:lnSpc>
+              <a:buNone/>
+            </a:pPr>
+            <a:r>
+              <a:rPr lang="en-US" sz="1600" dirty="0">
+                <a:solidFill>
+                  <a:srgbClr val="5A6072"/>
+                </a:solidFill>
+                <a:latin typeface="Calibri" pitchFamily="34" charset="0"/>
+                <a:ea typeface="Calibri" pitchFamily="34" charset="-122"/>
+                <a:cs typeface="Calibri" pitchFamily="34" charset="-120"/>
+              </a:rPr>
+              <a:t>End-to-end validation of PDF stream upload, vector scoring accuracy, and database transactions.</a:t>
+            </a:r>
+            <a:endParaRPr lang="en-US" sz="1600" dirty="0"/>
+          </a:p>
+        </p:txBody>
+      </p:sp>
+      <p:sp>
+        <p:nvSpPr>
+          <p:cNvPr id="18" name="Text 13"/>
+          <p:cNvSpPr/>
+          <p:nvPr/>
+        </p:nvSpPr>
+        <p:spPr>
+          <a:xfrm>
+            <a:off x="457200" y="6565392"/>
+            <a:ext cx="8229600" cy="274320"/>
+          </a:xfrm>
+          <a:prstGeom prst="rect">
+            <a:avLst/>
+          </a:prstGeom>
+          <a:noFill/>
+          <a:ln/>
+        </p:spPr>
+        <p:txBody>
+          <a:bodyPr wrap="square" rtlCol="0" anchor="ctr"/>
+          <a:lstStyle/>
+          <a:p>
+            <a:pPr marL="0" indent="0" algn="l">
+              <a:buNone/>
+            </a:pPr>
+            <a:r>
+              <a:rPr lang="en-US" sz="900" dirty="0">
+                <a:solidFill>
+                  <a:srgbClr val="8A90A6"/>
+                </a:solidFill>
+                <a:latin typeface="Calibri" pitchFamily="34" charset="0"/>
+                <a:ea typeface="Calibri" pitchFamily="34" charset="-122"/>
+                <a:cs typeface="Calibri" pitchFamily="34" charset="-120"/>
+              </a:rPr>
+              <a:t>Intelligent Invoice Processing &amp; Semantic Search Engine</a:t>
+            </a:r>
+            <a:endParaRPr lang="en-US" sz="900" dirty="0"/>
+          </a:p>
+        </p:txBody>
+      </p:sp>
+      <p:sp>
+        <p:nvSpPr>
+          <p:cNvPr id="19" name="Text 14"/>
+          <p:cNvSpPr/>
+          <p:nvPr/>
+        </p:nvSpPr>
+        <p:spPr>
+          <a:xfrm>
+            <a:off x="11521440" y="6565392"/>
+            <a:ext cx="457200" cy="274320"/>
+          </a:xfrm>
+          <a:prstGeom prst="rect">
+            <a:avLst/>
+          </a:prstGeom>
+          <a:noFill/>
+          <a:ln/>
+        </p:spPr>
+        <p:txBody>
+          <a:bodyPr wrap="square" rtlCol="0" anchor="ctr"/>
+          <a:lstStyle/>
+          <a:p>
+            <a:pPr marL="0" indent="0" algn="r">
+              <a:buNone/>
+            </a:pPr>
+            <a:r>
+              <a:rPr lang="en-US" sz="900" dirty="0">
+                <a:solidFill>
+                  <a:srgbClr val="8A90A6"/>
+                </a:solidFill>
+                <a:latin typeface="Calibri" pitchFamily="34" charset="0"/>
+                <a:ea typeface="Calibri" pitchFamily="34" charset="-122"/>
+                <a:cs typeface="Calibri" pitchFamily="34" charset="-120"/>
+              </a:rPr>
+              <a:t>10</a:t>
+            </a:r>
+            <a:endParaRPr lang="en-US" sz="900" dirty="0"/>
+          </a:p>
+        </p:txBody>
+      </p:sp>
+      <p:pic>
+        <p:nvPicPr>
+          <p:cNvPr id="27" name="Picture 26">
+            <a:extLst>
+              <a:ext uri="{FF2B5EF4-FFF2-40B4-BE49-F238E27FC236}">
+                <a16:creationId xmlns:a16="http://schemas.microsoft.com/office/drawing/2014/main" id="{6E9E7167-BC39-CD5D-D84A-6AB8AF28E16B}"/>
+              </a:ext>
+            </a:extLst>
+          </p:cNvPr>
+          <p:cNvPicPr>
+            <a:picLocks noChangeAspect="1"/>
+          </p:cNvPicPr>
+          <p:nvPr/>
+        </p:nvPicPr>
+        <p:blipFill>
+          <a:blip r:embed="rId3"/>
+          <a:stretch>
+            <a:fillRect/>
+          </a:stretch>
+        </p:blipFill>
+        <p:spPr>
+          <a:xfrm>
+            <a:off x="3748095" y="1298450"/>
+            <a:ext cx="8203082" cy="4547288"/>
           </a:xfrm>
           <a:prstGeom prst="rect">
             <a:avLst/>

</xml_diff>